<commit_message>
Switch deck font to MaruBuri
</commit_message>
<xml_diff>
--- a/moet_onview_popup_report_apple.pptx
+++ b/moet_onview_popup_report_apple.pptx
@@ -3168,9 +3168,9 @@
                 <a:solidFill>
                   <a:srgbClr val="0066CC"/>
                 </a:solidFill>
-                <a:latin typeface="Pretendard"/>
-                <a:ea typeface="Pretendard"/>
-                <a:cs typeface="Pretendard"/>
+                <a:latin typeface="마루부리"/>
+                <a:ea typeface="마루부리"/>
+                <a:cs typeface="마루부리"/>
               </a:rPr>
               <a:t>팝업 리테일 공간 분석 보고서</a:t>
             </a:r>
@@ -3205,9 +3205,9 @@
                 <a:solidFill>
                   <a:srgbClr val="0066CC"/>
                 </a:solidFill>
-                <a:latin typeface="Pretendard"/>
-                <a:ea typeface="Pretendard"/>
-                <a:cs typeface="Pretendard"/>
+                <a:latin typeface="마루부리"/>
+                <a:ea typeface="마루부리"/>
+                <a:cs typeface="마루부리"/>
               </a:rPr>
               <a:t>팝업 리테일 공간 분석 보고서</a:t>
             </a:r>
@@ -3246,9 +3246,9 @@
                 <a:solidFill>
                   <a:srgbClr val="1D1D1F"/>
                 </a:solidFill>
-                <a:latin typeface="Pretendard"/>
-                <a:ea typeface="Pretendard"/>
-                <a:cs typeface="Pretendard"/>
+                <a:latin typeface="마루부리"/>
+                <a:ea typeface="마루부리"/>
+                <a:cs typeface="마루부리"/>
               </a:rPr>
               <a:t>BEAUTY PLAYGROUND</a:t>
             </a:r>
@@ -3264,9 +3264,9 @@
                 <a:solidFill>
                   <a:srgbClr val="1D1D1F"/>
                 </a:solidFill>
-                <a:latin typeface="Pretendard"/>
-                <a:ea typeface="Pretendard"/>
-                <a:cs typeface="Pretendard"/>
+                <a:latin typeface="마루부리"/>
+                <a:ea typeface="마루부리"/>
+                <a:cs typeface="마루부리"/>
               </a:rPr>
               <a:t>IN SEONGSU</a:t>
             </a:r>
@@ -3305,9 +3305,9 @@
                 <a:solidFill>
                   <a:srgbClr val="333333"/>
                 </a:solidFill>
-                <a:latin typeface="Pretendard"/>
-                <a:ea typeface="Pretendard"/>
-                <a:cs typeface="Pretendard"/>
+                <a:latin typeface="마루부리"/>
+                <a:ea typeface="마루부리"/>
+                <a:cs typeface="마루부리"/>
               </a:rPr>
               <a:t>리테일 공간 팝업스토어 분석 보고서</a:t>
             </a:r>
@@ -3323,9 +3323,9 @@
                 <a:solidFill>
                   <a:srgbClr val="7A7A7A"/>
                 </a:solidFill>
-                <a:latin typeface="Pretendard"/>
-                <a:ea typeface="Pretendard"/>
-                <a:cs typeface="Pretendard"/>
+                <a:latin typeface="마루부리"/>
+                <a:ea typeface="마루부리"/>
+                <a:cs typeface="마루부리"/>
               </a:rPr>
               <a:t/>
             </a:r>
@@ -3341,9 +3341,9 @@
                 <a:solidFill>
                   <a:srgbClr val="7A7A7A"/>
                 </a:solidFill>
-                <a:latin typeface="Pretendard"/>
-                <a:ea typeface="Pretendard"/>
-                <a:cs typeface="Pretendard"/>
+                <a:latin typeface="마루부리"/>
+                <a:ea typeface="마루부리"/>
+                <a:cs typeface="마루부리"/>
               </a:rPr>
               <a:t>모에뜨(moét) 브랜드존 중심  ·  moét × ONVIEW</a:t>
             </a:r>
@@ -3424,9 +3424,9 @@
                 <a:solidFill>
                   <a:srgbClr val="FFFFFF"/>
                 </a:solidFill>
-                <a:latin typeface="Pretendard"/>
-                <a:ea typeface="Pretendard"/>
-                <a:cs typeface="Pretendard"/>
+                <a:latin typeface="마루부리"/>
+                <a:ea typeface="마루부리"/>
+                <a:cs typeface="마루부리"/>
               </a:rPr>
               <a:t>분석 개요</a:t>
             </a:r>
@@ -3507,9 +3507,9 @@
                 <a:solidFill>
                   <a:srgbClr val="0066CC"/>
                 </a:solidFill>
-                <a:latin typeface="Pretendard"/>
-                <a:ea typeface="Pretendard"/>
-                <a:cs typeface="Pretendard"/>
+                <a:latin typeface="마루부리"/>
+                <a:ea typeface="마루부리"/>
+                <a:cs typeface="마루부리"/>
               </a:rPr>
               <a:t>종합 의견</a:t>
             </a:r>
@@ -3580,9 +3580,9 @@
                 <a:solidFill>
                   <a:srgbClr val="7A7A7A"/>
                 </a:solidFill>
-                <a:latin typeface="Pretendard"/>
-                <a:ea typeface="Pretendard"/>
-                <a:cs typeface="Pretendard"/>
+                <a:latin typeface="마루부리"/>
+                <a:ea typeface="마루부리"/>
+                <a:cs typeface="마루부리"/>
               </a:rPr>
               <a:t>14주차 과제 레포트   ·   과목명 _______   ·   학번 _______   ·   이름 _______</a:t>
             </a:r>
@@ -3679,9 +3679,9 @@
                 <a:solidFill>
                   <a:srgbClr val="0066CC"/>
                 </a:solidFill>
-                <a:latin typeface="Pretendard"/>
-                <a:ea typeface="Pretendard"/>
-                <a:cs typeface="Pretendard"/>
+                <a:latin typeface="마루부리"/>
+                <a:ea typeface="마루부리"/>
+                <a:cs typeface="마루부리"/>
               </a:rPr>
               <a:t>OVERVIEW</a:t>
             </a:r>
@@ -3716,9 +3716,9 @@
                 <a:solidFill>
                   <a:srgbClr val="1D1D1F"/>
                 </a:solidFill>
-                <a:latin typeface="Pretendard"/>
-                <a:ea typeface="Pretendard"/>
-                <a:cs typeface="Pretendard"/>
+                <a:latin typeface="마루부리"/>
+                <a:ea typeface="마루부리"/>
+                <a:cs typeface="마루부리"/>
               </a:rPr>
               <a:t>개요</a:t>
             </a:r>
@@ -3789,9 +3789,9 @@
                 <a:solidFill>
                   <a:srgbClr val="0066CC"/>
                 </a:solidFill>
-                <a:latin typeface="Pretendard"/>
-                <a:ea typeface="Pretendard"/>
-                <a:cs typeface="Pretendard"/>
+                <a:latin typeface="마루부리"/>
+                <a:ea typeface="마루부리"/>
+                <a:cs typeface="마루부리"/>
               </a:rPr>
               <a:t>WHAT</a:t>
             </a:r>
@@ -3830,9 +3830,9 @@
                 <a:solidFill>
                   <a:srgbClr val="333333"/>
                 </a:solidFill>
-                <a:latin typeface="Pretendard"/>
-                <a:ea typeface="Pretendard"/>
-                <a:cs typeface="Pretendard"/>
+                <a:latin typeface="마루부리"/>
+                <a:ea typeface="마루부리"/>
+                <a:cs typeface="마루부리"/>
               </a:rPr>
               <a:t>성수동 중심가에서 개최된 인디 뷰티 큐레이션 플랫폼 ‘오엔뷰(ONVIEW)’와 모에뜨의 협업 팝업스토어. K-뷰티 고관여 MZ세대를 타깃으로, 일시적 제품 판매를 넘어 오감 체험(시향·제형)과 팝업 한정 리워드를 제공하는 ‘경험형 리테일 매장’으로 기획되었음.</a:t>
             </a:r>
@@ -3919,9 +3919,9 @@
                 <a:solidFill>
                   <a:srgbClr val="0066CC"/>
                 </a:solidFill>
-                <a:latin typeface="Pretendard"/>
-                <a:ea typeface="Pretendard"/>
-                <a:cs typeface="Pretendard"/>
+                <a:latin typeface="마루부리"/>
+                <a:ea typeface="마루부리"/>
+                <a:cs typeface="마루부리"/>
               </a:rPr>
               <a:t>운영 유의</a:t>
             </a:r>
@@ -3937,9 +3937,9 @@
                 <a:solidFill>
                   <a:srgbClr val="1D1D1F"/>
                 </a:solidFill>
-                <a:latin typeface="Pretendard"/>
-                <a:ea typeface="Pretendard"/>
-                <a:cs typeface="Pretendard"/>
+                <a:latin typeface="마루부리"/>
+                <a:ea typeface="마루부리"/>
+                <a:cs typeface="마루부리"/>
               </a:rPr>
               <a:t/>
             </a:r>
@@ -3955,9 +3955,9 @@
                 <a:solidFill>
                   <a:srgbClr val="1D1D1F"/>
                 </a:solidFill>
-                <a:latin typeface="Pretendard"/>
-                <a:ea typeface="Pretendard"/>
-                <a:cs typeface="Pretendard"/>
+                <a:latin typeface="마루부리"/>
+                <a:ea typeface="마루부리"/>
+                <a:cs typeface="마루부리"/>
               </a:rPr>
               <a:t>모에뜨 브랜드존은 6월 4일(목)까지만 조기 운영</a:t>
             </a:r>
@@ -4040,9 +4040,9 @@
                 <a:solidFill>
                   <a:srgbClr val="7A7A7A"/>
                 </a:solidFill>
-                <a:latin typeface="Pretendard"/>
-                <a:ea typeface="Pretendard"/>
-                <a:cs typeface="Pretendard"/>
+                <a:latin typeface="마루부리"/>
+                <a:ea typeface="마루부리"/>
+                <a:cs typeface="마루부리"/>
               </a:rPr>
               <a:t>브랜드</a:t>
             </a:r>
@@ -4081,9 +4081,9 @@
                 <a:solidFill>
                   <a:srgbClr val="1D1D1F"/>
                 </a:solidFill>
-                <a:latin typeface="Pretendard"/>
-                <a:ea typeface="Pretendard"/>
-                <a:cs typeface="Pretendard"/>
+                <a:latin typeface="마루부리"/>
+                <a:ea typeface="마루부리"/>
+                <a:cs typeface="마루부리"/>
               </a:rPr>
               <a:t>모에뜨 (moét)</a:t>
             </a:r>
@@ -4154,9 +4154,9 @@
                 <a:solidFill>
                   <a:srgbClr val="7A7A7A"/>
                 </a:solidFill>
-                <a:latin typeface="Pretendard"/>
-                <a:ea typeface="Pretendard"/>
-                <a:cs typeface="Pretendard"/>
+                <a:latin typeface="마루부리"/>
+                <a:ea typeface="마루부리"/>
+                <a:cs typeface="마루부리"/>
               </a:rPr>
               <a:t>팝업스토어명</a:t>
             </a:r>
@@ -4195,9 +4195,9 @@
                 <a:solidFill>
                   <a:srgbClr val="1D1D1F"/>
                 </a:solidFill>
-                <a:latin typeface="Pretendard"/>
-                <a:ea typeface="Pretendard"/>
-                <a:cs typeface="Pretendard"/>
+                <a:latin typeface="마루부리"/>
+                <a:ea typeface="마루부리"/>
+                <a:cs typeface="마루부리"/>
               </a:rPr>
               <a:t>BEAUTY PLAYGROUND IN SEONGSU</a:t>
             </a:r>
@@ -4268,9 +4268,9 @@
                 <a:solidFill>
                   <a:srgbClr val="7A7A7A"/>
                 </a:solidFill>
-                <a:latin typeface="Pretendard"/>
-                <a:ea typeface="Pretendard"/>
-                <a:cs typeface="Pretendard"/>
+                <a:latin typeface="마루부리"/>
+                <a:ea typeface="마루부리"/>
+                <a:cs typeface="마루부리"/>
               </a:rPr>
               <a:t>행사 기간</a:t>
             </a:r>
@@ -4309,9 +4309,9 @@
                 <a:solidFill>
                   <a:srgbClr val="1D1D1F"/>
                 </a:solidFill>
-                <a:latin typeface="Pretendard"/>
-                <a:ea typeface="Pretendard"/>
-                <a:cs typeface="Pretendard"/>
+                <a:latin typeface="마루부리"/>
+                <a:ea typeface="마루부리"/>
+                <a:cs typeface="마루부리"/>
               </a:rPr>
               <a:t>2026.05.22(금) ~ 06.10(수)</a:t>
             </a:r>
@@ -4382,9 +4382,9 @@
                 <a:solidFill>
                   <a:srgbClr val="7A7A7A"/>
                 </a:solidFill>
-                <a:latin typeface="Pretendard"/>
-                <a:ea typeface="Pretendard"/>
-                <a:cs typeface="Pretendard"/>
+                <a:latin typeface="마루부리"/>
+                <a:ea typeface="마루부리"/>
+                <a:cs typeface="마루부리"/>
               </a:rPr>
               <a:t>운영 시간</a:t>
             </a:r>
@@ -4423,9 +4423,9 @@
                 <a:solidFill>
                   <a:srgbClr val="1D1D1F"/>
                 </a:solidFill>
-                <a:latin typeface="Pretendard"/>
-                <a:ea typeface="Pretendard"/>
-                <a:cs typeface="Pretendard"/>
+                <a:latin typeface="마루부리"/>
+                <a:ea typeface="마루부리"/>
+                <a:cs typeface="마루부리"/>
               </a:rPr>
               <a:t>11:00 ~ 19:00 (입장 마감 18:30)</a:t>
             </a:r>
@@ -4496,9 +4496,9 @@
                 <a:solidFill>
                   <a:srgbClr val="7A7A7A"/>
                 </a:solidFill>
-                <a:latin typeface="Pretendard"/>
-                <a:ea typeface="Pretendard"/>
-                <a:cs typeface="Pretendard"/>
+                <a:latin typeface="마루부리"/>
+                <a:ea typeface="마루부리"/>
+                <a:cs typeface="마루부리"/>
               </a:rPr>
               <a:t>장소</a:t>
             </a:r>
@@ -4537,9 +4537,9 @@
                 <a:solidFill>
                   <a:srgbClr val="1D1D1F"/>
                 </a:solidFill>
-                <a:latin typeface="Pretendard"/>
-                <a:ea typeface="Pretendard"/>
-                <a:cs typeface="Pretendard"/>
+                <a:latin typeface="마루부리"/>
+                <a:ea typeface="마루부리"/>
+                <a:cs typeface="마루부리"/>
               </a:rPr>
               <a:t>맵달SEOUL 성수 3F</a:t>
             </a:r>
@@ -4555,9 +4555,9 @@
                 <a:solidFill>
                   <a:srgbClr val="1D1D1F"/>
                 </a:solidFill>
-                <a:latin typeface="Pretendard"/>
-                <a:ea typeface="Pretendard"/>
-                <a:cs typeface="Pretendard"/>
+                <a:latin typeface="마루부리"/>
+                <a:ea typeface="마루부리"/>
+                <a:cs typeface="마루부리"/>
               </a:rPr>
               <a:t>성동구 성수이로16길 5</a:t>
             </a:r>
@@ -4592,9 +4592,9 @@
                 <a:solidFill>
                   <a:srgbClr val="7A7A7A"/>
                 </a:solidFill>
-                <a:latin typeface="Pretendard"/>
-                <a:ea typeface="Pretendard"/>
-                <a:cs typeface="Pretendard"/>
+                <a:latin typeface="마루부리"/>
+                <a:ea typeface="마루부리"/>
+                <a:cs typeface="마루부리"/>
               </a:rPr>
               <a:t>moét × ONVIEW · BEAUTY PLAYGROUND IN SEONGSU</a:t>
             </a:r>
@@ -4629,9 +4629,9 @@
                 <a:solidFill>
                   <a:srgbClr val="7A7A7A"/>
                 </a:solidFill>
-                <a:latin typeface="Pretendard"/>
-                <a:ea typeface="Pretendard"/>
-                <a:cs typeface="Pretendard"/>
+                <a:latin typeface="마루부리"/>
+                <a:ea typeface="마루부리"/>
+                <a:cs typeface="마루부리"/>
               </a:rPr>
               <a:t>02 / 09</a:t>
             </a:r>
@@ -4728,9 +4728,9 @@
                 <a:solidFill>
                   <a:srgbClr val="2997FF"/>
                 </a:solidFill>
-                <a:latin typeface="Pretendard"/>
-                <a:ea typeface="Pretendard"/>
-                <a:cs typeface="Pretendard"/>
+                <a:latin typeface="마루부리"/>
+                <a:ea typeface="마루부리"/>
+                <a:cs typeface="마루부리"/>
               </a:rPr>
               <a:t>01  LOCALITY</a:t>
             </a:r>
@@ -4765,9 +4765,9 @@
                 <a:solidFill>
                   <a:srgbClr val="FFFFFF"/>
                 </a:solidFill>
-                <a:latin typeface="Pretendard"/>
-                <a:ea typeface="Pretendard"/>
-                <a:cs typeface="Pretendard"/>
+                <a:latin typeface="마루부리"/>
+                <a:ea typeface="마루부리"/>
+                <a:cs typeface="마루부리"/>
               </a:rPr>
               <a:t>장소성</a:t>
             </a:r>
@@ -4806,9 +4806,9 @@
                 <a:solidFill>
                   <a:srgbClr val="CCCCCC"/>
                 </a:solidFill>
-                <a:latin typeface="Pretendard"/>
-                <a:ea typeface="Pretendard"/>
-                <a:cs typeface="Pretendard"/>
+                <a:latin typeface="마루부리"/>
+                <a:ea typeface="마루부리"/>
+                <a:cs typeface="마루부리"/>
               </a:rPr>
               <a:t>트렌드세터의 중심지, 성수동 상권과의 유기적 결합</a:t>
             </a:r>
@@ -4935,9 +4935,9 @@
                 <a:solidFill>
                   <a:srgbClr val="FFFFFF"/>
                 </a:solidFill>
-                <a:latin typeface="Pretendard"/>
-                <a:ea typeface="Pretendard"/>
-                <a:cs typeface="Pretendard"/>
+                <a:latin typeface="마루부리"/>
+                <a:ea typeface="마루부리"/>
+                <a:cs typeface="마루부리"/>
               </a:rPr>
               <a:t>트렌디한 소비층 밀집</a:t>
             </a:r>
@@ -4976,9 +4976,9 @@
                 <a:solidFill>
                   <a:srgbClr val="CCCCCC"/>
                 </a:solidFill>
-                <a:latin typeface="Pretendard"/>
-                <a:ea typeface="Pretendard"/>
-                <a:cs typeface="Pretendard"/>
+                <a:latin typeface="마루부리"/>
+                <a:ea typeface="마루부리"/>
+                <a:cs typeface="마루부리"/>
               </a:rPr>
               <a:t>국내외 MZ세대 및 K-뷰티 고관여 소비자가 가장 활발하게 유입되는 서울 성수동 중심 상권에 위치.</a:t>
             </a:r>
@@ -5059,9 +5059,9 @@
                 <a:solidFill>
                   <a:srgbClr val="FFFFFF"/>
                 </a:solidFill>
-                <a:latin typeface="Pretendard"/>
-                <a:ea typeface="Pretendard"/>
-                <a:cs typeface="Pretendard"/>
+                <a:latin typeface="마루부리"/>
+                <a:ea typeface="마루부리"/>
+                <a:cs typeface="마루부리"/>
               </a:rPr>
               <a:t>우수한 접근성</a:t>
             </a:r>
@@ -5100,9 +5100,9 @@
                 <a:solidFill>
                   <a:srgbClr val="CCCCCC"/>
                 </a:solidFill>
-                <a:latin typeface="Pretendard"/>
-                <a:ea typeface="Pretendard"/>
-                <a:cs typeface="Pretendard"/>
+                <a:latin typeface="마루부리"/>
+                <a:ea typeface="마루부리"/>
+                <a:cs typeface="마루부리"/>
               </a:rPr>
               <a:t>성수역 3번 출구에서 도보 5분 거리에 위치해 자연스러운 도보 방문객 유입률 확보.</a:t>
             </a:r>
@@ -5183,9 +5183,9 @@
                 <a:solidFill>
                   <a:srgbClr val="FFFFFF"/>
                 </a:solidFill>
-                <a:latin typeface="Pretendard"/>
-                <a:ea typeface="Pretendard"/>
-                <a:cs typeface="Pretendard"/>
+                <a:latin typeface="마루부리"/>
+                <a:ea typeface="마루부리"/>
+                <a:cs typeface="마루부리"/>
               </a:rPr>
               <a:t>공간의 적합성</a:t>
             </a:r>
@@ -5224,9 +5224,9 @@
                 <a:solidFill>
                   <a:srgbClr val="CCCCCC"/>
                 </a:solidFill>
-                <a:latin typeface="Pretendard"/>
-                <a:ea typeface="Pretendard"/>
-                <a:cs typeface="Pretendard"/>
+                <a:latin typeface="마루부리"/>
+                <a:ea typeface="마루부리"/>
+                <a:cs typeface="마루부리"/>
               </a:rPr>
               <a:t>‘맵달서울’ 3층을 활용, 대형 채널에서 못 보던 신선한 인디 뷰티를 발굴·체험하는 성수동 특유의 감성과 시너지.</a:t>
             </a:r>
@@ -5364,9 +5364,9 @@
                 <a:solidFill>
                   <a:srgbClr val="CCCCCC"/>
                 </a:solidFill>
-                <a:latin typeface="Pretendard"/>
-                <a:ea typeface="Pretendard"/>
-                <a:cs typeface="Pretendard"/>
+                <a:latin typeface="마루부리"/>
+                <a:ea typeface="마루부리"/>
+                <a:cs typeface="마루부리"/>
               </a:rPr>
               <a:t>제품/현장 이미지</a:t>
             </a:r>
@@ -5382,9 +5382,9 @@
                 <a:solidFill>
                   <a:srgbClr val="CCCCCC"/>
                 </a:solidFill>
-                <a:latin typeface="Pretendard"/>
-                <a:ea typeface="Pretendard"/>
-                <a:cs typeface="Pretendard"/>
+                <a:latin typeface="마루부리"/>
+                <a:ea typeface="마루부리"/>
+                <a:cs typeface="마루부리"/>
               </a:rPr>
               <a:t/>
             </a:r>
@@ -5400,9 +5400,9 @@
                 <a:solidFill>
                   <a:srgbClr val="CCCCCC"/>
                 </a:solidFill>
-                <a:latin typeface="Pretendard"/>
-                <a:ea typeface="Pretendard"/>
-                <a:cs typeface="Pretendard"/>
+                <a:latin typeface="마루부리"/>
+                <a:ea typeface="마루부리"/>
+                <a:cs typeface="마루부리"/>
               </a:rPr>
               <a:t>3층 행사장 진입 복도 및 입구 대기 줄</a:t>
             </a:r>
@@ -5437,9 +5437,9 @@
                 <a:solidFill>
                   <a:srgbClr val="CCCCCC"/>
                 </a:solidFill>
-                <a:latin typeface="Pretendard"/>
-                <a:ea typeface="Pretendard"/>
-                <a:cs typeface="Pretendard"/>
+                <a:latin typeface="마루부리"/>
+                <a:ea typeface="마루부리"/>
+                <a:cs typeface="마루부리"/>
               </a:rPr>
               <a:t>moét × ONVIEW · BEAUTY PLAYGROUND IN SEONGSU</a:t>
             </a:r>
@@ -5474,9 +5474,9 @@
                 <a:solidFill>
                   <a:srgbClr val="CCCCCC"/>
                 </a:solidFill>
-                <a:latin typeface="Pretendard"/>
-                <a:ea typeface="Pretendard"/>
-                <a:cs typeface="Pretendard"/>
+                <a:latin typeface="마루부리"/>
+                <a:ea typeface="마루부리"/>
+                <a:cs typeface="마루부리"/>
               </a:rPr>
               <a:t>03 / 09</a:t>
             </a:r>
@@ -5573,9 +5573,9 @@
                 <a:solidFill>
                   <a:srgbClr val="0066CC"/>
                 </a:solidFill>
-                <a:latin typeface="Pretendard"/>
-                <a:ea typeface="Pretendard"/>
-                <a:cs typeface="Pretendard"/>
+                <a:latin typeface="마루부리"/>
+                <a:ea typeface="마루부리"/>
+                <a:cs typeface="마루부리"/>
               </a:rPr>
               <a:t>02  SYMBOLISM</a:t>
             </a:r>
@@ -5610,9 +5610,9 @@
                 <a:solidFill>
                   <a:srgbClr val="1D1D1F"/>
                 </a:solidFill>
-                <a:latin typeface="Pretendard"/>
-                <a:ea typeface="Pretendard"/>
-                <a:cs typeface="Pretendard"/>
+                <a:latin typeface="마루부리"/>
+                <a:ea typeface="마루부리"/>
+                <a:cs typeface="마루부리"/>
               </a:rPr>
               <a:t>상징성</a:t>
             </a:r>
@@ -5651,9 +5651,9 @@
                 <a:solidFill>
                   <a:srgbClr val="7A7A7A"/>
                 </a:solidFill>
-                <a:latin typeface="Pretendard"/>
-                <a:ea typeface="Pretendard"/>
-                <a:cs typeface="Pretendard"/>
+                <a:latin typeface="마루부리"/>
+                <a:ea typeface="마루부리"/>
+                <a:cs typeface="마루부리"/>
               </a:rPr>
               <a:t>상품 · 컬러 · 컨셉 · 브랜드 메시지로 구축한 브랜드 아이덴티티</a:t>
             </a:r>
@@ -5736,9 +5736,9 @@
                 <a:solidFill>
                   <a:srgbClr val="1D1D1F"/>
                 </a:solidFill>
-                <a:latin typeface="Pretendard"/>
-                <a:ea typeface="Pretendard"/>
-                <a:cs typeface="Pretendard"/>
+                <a:latin typeface="마루부리"/>
+                <a:ea typeface="마루부리"/>
+                <a:cs typeface="마루부리"/>
               </a:rPr>
               <a:t>[1] 상품  Products</a:t>
             </a:r>
@@ -5777,9 +5777,9 @@
                 <a:solidFill>
                   <a:srgbClr val="333333"/>
                 </a:solidFill>
-                <a:latin typeface="Pretendard"/>
-                <a:ea typeface="Pretendard"/>
-                <a:cs typeface="Pretendard"/>
+                <a:latin typeface="마루부리"/>
+                <a:ea typeface="마루부리"/>
+                <a:cs typeface="마루부리"/>
               </a:rPr>
               <a:t>시그니처 스칼프 샴푸(톳수·창포뿌리줄기수 베이스, 식약처 허가 최대치 식물성 카페인)와 두피 앰플(마이크로 스피큘 니들샷 공법)을 중앙 매대에 배치, 고기능성 기술력을 직관적으로 체험.</a:t>
             </a:r>
@@ -5862,9 +5862,9 @@
                 <a:solidFill>
                   <a:srgbClr val="1D1D1F"/>
                 </a:solidFill>
-                <a:latin typeface="Pretendard"/>
-                <a:ea typeface="Pretendard"/>
-                <a:cs typeface="Pretendard"/>
+                <a:latin typeface="마루부리"/>
+                <a:ea typeface="마루부리"/>
+                <a:cs typeface="마루부리"/>
               </a:rPr>
               <a:t>[2] 컬러  Color</a:t>
             </a:r>
@@ -5903,9 +5903,9 @@
                 <a:solidFill>
                   <a:srgbClr val="333333"/>
                 </a:solidFill>
-                <a:latin typeface="Pretendard"/>
-                <a:ea typeface="Pretendard"/>
-                <a:cs typeface="Pretendard"/>
+                <a:latin typeface="마루부리"/>
+                <a:ea typeface="마루부리"/>
+                <a:cs typeface="마루부리"/>
               </a:rPr>
               <a:t>메인 스카이 블루(청량함·두피 회복)로 시선을 사로잡고, 미니멀 화이트&amp;그레이(정직함·과학적 근거)로 패키지·베이스 톤을 구성해 신뢰감 있는 무드 조성.</a:t>
             </a:r>
@@ -5988,9 +5988,9 @@
                 <a:solidFill>
                   <a:srgbClr val="1D1D1F"/>
                 </a:solidFill>
-                <a:latin typeface="Pretendard"/>
-                <a:ea typeface="Pretendard"/>
-                <a:cs typeface="Pretendard"/>
+                <a:latin typeface="마루부리"/>
+                <a:ea typeface="마루부리"/>
+                <a:cs typeface="마루부리"/>
               </a:rPr>
               <a:t>[3] 컨셉  Concept</a:t>
             </a:r>
@@ -6029,9 +6029,9 @@
                 <a:solidFill>
                   <a:srgbClr val="333333"/>
                 </a:solidFill>
-                <a:latin typeface="Pretendard"/>
-                <a:ea typeface="Pretendard"/>
-                <a:cs typeface="Pretendard"/>
+                <a:latin typeface="마루부리"/>
+                <a:ea typeface="마루부리"/>
+                <a:cs typeface="마루부리"/>
               </a:rPr>
               <a:t>원료 설명 카드·감성 엽서로 ‘정직한 성분 연구소’를 전달. 스크런치 안내와 티코스터 증정을 통해 ‘산뜻한 데일리 루틴’을 경험으로 소유하게 설계.</a:t>
             </a:r>
@@ -6160,9 +6160,9 @@
                 <a:solidFill>
                   <a:srgbClr val="1D1D1F"/>
                 </a:solidFill>
-                <a:latin typeface="Pretendard"/>
-                <a:ea typeface="Pretendard"/>
-                <a:cs typeface="Pretendard"/>
+                <a:latin typeface="마루부리"/>
+                <a:ea typeface="마루부리"/>
+                <a:cs typeface="마루부리"/>
               </a:rPr>
               <a:t>[4] 브랜드 메시지  Message</a:t>
             </a:r>
@@ -6201,9 +6201,9 @@
                 <a:solidFill>
                   <a:srgbClr val="333333"/>
                 </a:solidFill>
-                <a:latin typeface="Pretendard"/>
-                <a:ea typeface="Pretendard"/>
-                <a:cs typeface="Pretendard"/>
+                <a:latin typeface="마루부리"/>
+                <a:ea typeface="마루부리"/>
+                <a:cs typeface="마루부리"/>
               </a:rPr>
               <a:t>“Pure Origin, Real Change” — 순수한 핵심 원료(Pure Origin)를 고함량 설계해 실제 두피 개선과 긍정적 효과(Real Change)를 체감하게 한다는 약속.</a:t>
             </a:r>
@@ -6238,9 +6238,9 @@
                 <a:solidFill>
                   <a:srgbClr val="7A7A7A"/>
                 </a:solidFill>
-                <a:latin typeface="Pretendard"/>
-                <a:ea typeface="Pretendard"/>
-                <a:cs typeface="Pretendard"/>
+                <a:latin typeface="마루부리"/>
+                <a:ea typeface="마루부리"/>
+                <a:cs typeface="마루부리"/>
               </a:rPr>
               <a:t>moét × ONVIEW · BEAUTY PLAYGROUND IN SEONGSU</a:t>
             </a:r>
@@ -6275,9 +6275,9 @@
                 <a:solidFill>
                   <a:srgbClr val="7A7A7A"/>
                 </a:solidFill>
-                <a:latin typeface="Pretendard"/>
-                <a:ea typeface="Pretendard"/>
-                <a:cs typeface="Pretendard"/>
+                <a:latin typeface="마루부리"/>
+                <a:ea typeface="마루부리"/>
+                <a:cs typeface="마루부리"/>
               </a:rPr>
               <a:t>04 / 09</a:t>
             </a:r>
@@ -6374,9 +6374,9 @@
                 <a:solidFill>
                   <a:srgbClr val="2997FF"/>
                 </a:solidFill>
-                <a:latin typeface="Pretendard"/>
-                <a:ea typeface="Pretendard"/>
-                <a:cs typeface="Pretendard"/>
+                <a:latin typeface="마루부리"/>
+                <a:ea typeface="마루부리"/>
+                <a:cs typeface="마루부리"/>
               </a:rPr>
               <a:t>03  THEMATIC</a:t>
             </a:r>
@@ -6411,9 +6411,9 @@
                 <a:solidFill>
                   <a:srgbClr val="FFFFFF"/>
                 </a:solidFill>
-                <a:latin typeface="Pretendard"/>
-                <a:ea typeface="Pretendard"/>
-                <a:cs typeface="Pretendard"/>
+                <a:latin typeface="마루부리"/>
+                <a:ea typeface="마루부리"/>
+                <a:cs typeface="마루부리"/>
               </a:rPr>
               <a:t>테마성</a:t>
             </a:r>
@@ -6452,9 +6452,9 @@
                 <a:solidFill>
                   <a:srgbClr val="CCCCCC"/>
                 </a:solidFill>
-                <a:latin typeface="Pretendard"/>
-                <a:ea typeface="Pretendard"/>
-                <a:cs typeface="Pretendard"/>
+                <a:latin typeface="마루부리"/>
+                <a:ea typeface="마루부리"/>
+                <a:cs typeface="마루부리"/>
               </a:rPr>
               <a:t>‘Pure Origin, Real Change’ — 체험 중심의 고기능성 헤어 랩(Lab)</a:t>
             </a:r>
@@ -6581,9 +6581,9 @@
                 <a:solidFill>
                   <a:srgbClr val="FFFFFF"/>
                 </a:solidFill>
-                <a:latin typeface="Pretendard"/>
-                <a:ea typeface="Pretendard"/>
-                <a:cs typeface="Pretendard"/>
+                <a:latin typeface="마루부리"/>
+                <a:ea typeface="마루부리"/>
+                <a:cs typeface="마루부리"/>
               </a:rPr>
               <a:t>메인 테마의 구체화</a:t>
             </a:r>
@@ -6622,9 +6622,9 @@
                 <a:solidFill>
                   <a:srgbClr val="CCCCCC"/>
                 </a:solidFill>
-                <a:latin typeface="Pretendard"/>
-                <a:ea typeface="Pretendard"/>
-                <a:cs typeface="Pretendard"/>
+                <a:latin typeface="마루부리"/>
+                <a:ea typeface="마루부리"/>
+                <a:cs typeface="마루부리"/>
               </a:rPr>
               <a:t>‘뷰티 놀이터(Playground)’라는 전체 테마 속에서 ‘자극 없는 일상 속 두피 회복 솔루션’을 서브 테마로 명확히 제안.</a:t>
             </a:r>
@@ -6705,9 +6705,9 @@
                 <a:solidFill>
                   <a:srgbClr val="FFFFFF"/>
                 </a:solidFill>
-                <a:latin typeface="Pretendard"/>
-                <a:ea typeface="Pretendard"/>
-                <a:cs typeface="Pretendard"/>
+                <a:latin typeface="마루부리"/>
+                <a:ea typeface="마루부리"/>
+                <a:cs typeface="마루부리"/>
               </a:rPr>
               <a:t>콘셉추얼한 매대 구성</a:t>
             </a:r>
@@ -6746,9 +6746,9 @@
                 <a:solidFill>
                   <a:srgbClr val="CCCCCC"/>
                 </a:solidFill>
-                <a:latin typeface="Pretendard"/>
-                <a:ea typeface="Pretendard"/>
-                <a:cs typeface="Pretendard"/>
+                <a:latin typeface="마루부리"/>
+                <a:ea typeface="마루부리"/>
+                <a:cs typeface="마루부리"/>
               </a:rPr>
               <a:t>단순 진열·판매를 넘어, 방문객이 자신의 두피 고민(열감·모발 빠짐·유분)을 인지하고 해답을 스스로 탐색하는 서사적 공간으로 연출.</a:t>
             </a:r>
@@ -6886,9 +6886,9 @@
                 <a:solidFill>
                   <a:srgbClr val="CCCCCC"/>
                 </a:solidFill>
-                <a:latin typeface="Pretendard"/>
-                <a:ea typeface="Pretendard"/>
-                <a:cs typeface="Pretendard"/>
+                <a:latin typeface="마루부리"/>
+                <a:ea typeface="마루부리"/>
+                <a:cs typeface="마루부리"/>
               </a:rPr>
               <a:t>제품/현장 이미지</a:t>
             </a:r>
@@ -6904,9 +6904,9 @@
                 <a:solidFill>
                   <a:srgbClr val="CCCCCC"/>
                 </a:solidFill>
-                <a:latin typeface="Pretendard"/>
-                <a:ea typeface="Pretendard"/>
-                <a:cs typeface="Pretendard"/>
+                <a:latin typeface="마루부리"/>
+                <a:ea typeface="마루부리"/>
+                <a:cs typeface="마루부리"/>
               </a:rPr>
               <a:t/>
             </a:r>
@@ -6922,9 +6922,9 @@
                 <a:solidFill>
                   <a:srgbClr val="CCCCCC"/>
                 </a:solidFill>
-                <a:latin typeface="Pretendard"/>
-                <a:ea typeface="Pretendard"/>
-                <a:cs typeface="Pretendard"/>
+                <a:latin typeface="마루부리"/>
+                <a:ea typeface="마루부리"/>
+                <a:cs typeface="마루부리"/>
               </a:rPr>
               <a:t>원료 설명 리플렛·감성 엽서가 함께 디스플레이된 매대</a:t>
             </a:r>
@@ -6959,9 +6959,9 @@
                 <a:solidFill>
                   <a:srgbClr val="CCCCCC"/>
                 </a:solidFill>
-                <a:latin typeface="Pretendard"/>
-                <a:ea typeface="Pretendard"/>
-                <a:cs typeface="Pretendard"/>
+                <a:latin typeface="마루부리"/>
+                <a:ea typeface="마루부리"/>
+                <a:cs typeface="마루부리"/>
               </a:rPr>
               <a:t>moét × ONVIEW · BEAUTY PLAYGROUND IN SEONGSU</a:t>
             </a:r>
@@ -6996,9 +6996,9 @@
                 <a:solidFill>
                   <a:srgbClr val="CCCCCC"/>
                 </a:solidFill>
-                <a:latin typeface="Pretendard"/>
-                <a:ea typeface="Pretendard"/>
-                <a:cs typeface="Pretendard"/>
+                <a:latin typeface="마루부리"/>
+                <a:ea typeface="마루부리"/>
+                <a:cs typeface="마루부리"/>
               </a:rPr>
               <a:t>05 / 09</a:t>
             </a:r>
@@ -7095,9 +7095,9 @@
                 <a:solidFill>
                   <a:srgbClr val="0066CC"/>
                 </a:solidFill>
-                <a:latin typeface="Pretendard"/>
-                <a:ea typeface="Pretendard"/>
-                <a:cs typeface="Pretendard"/>
+                <a:latin typeface="마루부리"/>
+                <a:ea typeface="마루부리"/>
+                <a:cs typeface="마루부리"/>
               </a:rPr>
               <a:t>04  CONTENTS</a:t>
             </a:r>
@@ -7132,9 +7132,9 @@
                 <a:solidFill>
                   <a:srgbClr val="1D1D1F"/>
                 </a:solidFill>
-                <a:latin typeface="Pretendard"/>
-                <a:ea typeface="Pretendard"/>
-                <a:cs typeface="Pretendard"/>
+                <a:latin typeface="마루부리"/>
+                <a:ea typeface="마루부리"/>
+                <a:cs typeface="마루부리"/>
               </a:rPr>
               <a:t>콘텐츠</a:t>
             </a:r>
@@ -7173,9 +7173,9 @@
                 <a:solidFill>
                   <a:srgbClr val="7A7A7A"/>
                 </a:solidFill>
-                <a:latin typeface="Pretendard"/>
-                <a:ea typeface="Pretendard"/>
-                <a:cs typeface="Pretendard"/>
+                <a:latin typeface="마루부리"/>
+                <a:ea typeface="마루부리"/>
+                <a:cs typeface="마루부리"/>
               </a:rPr>
               <a:t>방문객의 오감을 자극하는 참여형 저니(Journey) 설계</a:t>
             </a:r>
@@ -7258,9 +7258,9 @@
                 <a:solidFill>
                   <a:srgbClr val="1D1D1F"/>
                 </a:solidFill>
-                <a:latin typeface="Pretendard"/>
-                <a:ea typeface="Pretendard"/>
-                <a:cs typeface="Pretendard"/>
+                <a:latin typeface="마루부리"/>
+                <a:ea typeface="마루부리"/>
+                <a:cs typeface="마루부리"/>
               </a:rPr>
               <a:t>원료 스토리텔링 · 시향</a:t>
             </a:r>
@@ -7299,9 +7299,9 @@
                 <a:solidFill>
                   <a:srgbClr val="333333"/>
                 </a:solidFill>
-                <a:latin typeface="Pretendard"/>
-                <a:ea typeface="Pretendard"/>
-                <a:cs typeface="Pretendard"/>
+                <a:latin typeface="마루부리"/>
+                <a:ea typeface="마루부리"/>
+                <a:cs typeface="마루부리"/>
               </a:rPr>
               <a:t>특허 ‘톳인삼농축액’, 고함량 식물성 카페인을 코칭하고, 세련된 플로럴 머스크 향을 직접 맡게 하는 청각·후각 콘텐츠.</a:t>
             </a:r>
@@ -7430,9 +7430,9 @@
                 <a:solidFill>
                   <a:srgbClr val="1D1D1F"/>
                 </a:solidFill>
-                <a:latin typeface="Pretendard"/>
-                <a:ea typeface="Pretendard"/>
-                <a:cs typeface="Pretendard"/>
+                <a:latin typeface="마루부리"/>
+                <a:ea typeface="마루부리"/>
+                <a:cs typeface="마루부리"/>
               </a:rPr>
               <a:t>촉각적 제형 테스트</a:t>
             </a:r>
@@ -7471,9 +7471,9 @@
                 <a:solidFill>
                   <a:srgbClr val="333333"/>
                 </a:solidFill>
-                <a:latin typeface="Pretendard"/>
-                <a:ea typeface="Pretendard"/>
-                <a:cs typeface="Pretendard"/>
+                <a:latin typeface="마루부리"/>
+                <a:ea typeface="마루부리"/>
+                <a:cs typeface="마루부리"/>
               </a:rPr>
               <a:t>마이크로 스피큘(니들샷) 두피 앰플을 손등에 발라보게 해 ‘끈적임 없는 흡수력’과 ‘즉각적 쿨링감’을 현장 체감.</a:t>
             </a:r>
@@ -7556,9 +7556,9 @@
                 <a:solidFill>
                   <a:srgbClr val="1D1D1F"/>
                 </a:solidFill>
-                <a:latin typeface="Pretendard"/>
-                <a:ea typeface="Pretendard"/>
-                <a:cs typeface="Pretendard"/>
+                <a:latin typeface="마루부리"/>
+                <a:ea typeface="마루부리"/>
+                <a:cs typeface="마루부리"/>
               </a:rPr>
               <a:t>엔터테인먼트 요소</a:t>
             </a:r>
@@ -7597,9 +7597,9 @@
                 <a:solidFill>
                   <a:srgbClr val="333333"/>
                 </a:solidFill>
-                <a:latin typeface="Pretendard"/>
-                <a:ea typeface="Pretendard"/>
-                <a:cs typeface="Pretendard"/>
+                <a:latin typeface="마루부리"/>
+                <a:ea typeface="마루부리"/>
+                <a:cs typeface="마루부리"/>
               </a:rPr>
               <a:t>카카오톡 채널 추가·인스타그램 팔로우 시 ‘꽝 없는 100% 당첨 럭키드로우’ 뽑기 게임으로 참여 재미 극대화.</a:t>
             </a:r>
@@ -7737,9 +7737,9 @@
                 <a:solidFill>
                   <a:srgbClr val="7A7A7A"/>
                 </a:solidFill>
-                <a:latin typeface="Pretendard"/>
-                <a:ea typeface="Pretendard"/>
-                <a:cs typeface="Pretendard"/>
+                <a:latin typeface="마루부리"/>
+                <a:ea typeface="마루부리"/>
+                <a:cs typeface="마루부리"/>
               </a:rPr>
               <a:t>제품/현장 이미지</a:t>
             </a:r>
@@ -7755,9 +7755,9 @@
                 <a:solidFill>
                   <a:srgbClr val="7A7A7A"/>
                 </a:solidFill>
-                <a:latin typeface="Pretendard"/>
-                <a:ea typeface="Pretendard"/>
-                <a:cs typeface="Pretendard"/>
+                <a:latin typeface="마루부리"/>
+                <a:ea typeface="마루부리"/>
+                <a:cs typeface="마루부리"/>
               </a:rPr>
               <a:t/>
             </a:r>
@@ -7773,9 +7773,9 @@
                 <a:solidFill>
                   <a:srgbClr val="7A7A7A"/>
                 </a:solidFill>
-                <a:latin typeface="Pretendard"/>
-                <a:ea typeface="Pretendard"/>
-                <a:cs typeface="Pretendard"/>
+                <a:latin typeface="마루부리"/>
+                <a:ea typeface="마루부리"/>
+                <a:cs typeface="마루부리"/>
               </a:rPr>
               <a:t>두피 앰플 테스팅 장면 및 럭키드로우 돌리기 기계</a:t>
             </a:r>
@@ -7810,9 +7810,9 @@
                 <a:solidFill>
                   <a:srgbClr val="7A7A7A"/>
                 </a:solidFill>
-                <a:latin typeface="Pretendard"/>
-                <a:ea typeface="Pretendard"/>
-                <a:cs typeface="Pretendard"/>
+                <a:latin typeface="마루부리"/>
+                <a:ea typeface="마루부리"/>
+                <a:cs typeface="마루부리"/>
               </a:rPr>
               <a:t>moét × ONVIEW · BEAUTY PLAYGROUND IN SEONGSU</a:t>
             </a:r>
@@ -7847,9 +7847,9 @@
                 <a:solidFill>
                   <a:srgbClr val="7A7A7A"/>
                 </a:solidFill>
-                <a:latin typeface="Pretendard"/>
-                <a:ea typeface="Pretendard"/>
-                <a:cs typeface="Pretendard"/>
+                <a:latin typeface="마루부리"/>
+                <a:ea typeface="마루부리"/>
+                <a:cs typeface="마루부리"/>
               </a:rPr>
               <a:t>06 / 09</a:t>
             </a:r>
@@ -7946,9 +7946,9 @@
                 <a:solidFill>
                   <a:srgbClr val="2997FF"/>
                 </a:solidFill>
-                <a:latin typeface="Pretendard"/>
-                <a:ea typeface="Pretendard"/>
-                <a:cs typeface="Pretendard"/>
+                <a:latin typeface="마루부리"/>
+                <a:ea typeface="마루부리"/>
+                <a:cs typeface="마루부리"/>
               </a:rPr>
               <a:t>05  BUZZ</a:t>
             </a:r>
@@ -7983,9 +7983,9 @@
                 <a:solidFill>
                   <a:srgbClr val="FFFFFF"/>
                 </a:solidFill>
-                <a:latin typeface="Pretendard"/>
-                <a:ea typeface="Pretendard"/>
-                <a:cs typeface="Pretendard"/>
+                <a:latin typeface="마루부리"/>
+                <a:ea typeface="마루부리"/>
+                <a:cs typeface="마루부리"/>
               </a:rPr>
               <a:t>화제성</a:t>
             </a:r>
@@ -8024,9 +8024,9 @@
                 <a:solidFill>
                   <a:srgbClr val="CCCCCC"/>
                 </a:solidFill>
-                <a:latin typeface="Pretendard"/>
-                <a:ea typeface="Pretendard"/>
-                <a:cs typeface="Pretendard"/>
+                <a:latin typeface="마루부리"/>
+                <a:ea typeface="마루부리"/>
+                <a:cs typeface="마루부리"/>
               </a:rPr>
               <a:t>‘혜자 팝업’ 입소문과 SNS 자발적 바이럴 효과</a:t>
             </a:r>
@@ -8153,9 +8153,9 @@
                 <a:solidFill>
                   <a:srgbClr val="FFFFFF"/>
                 </a:solidFill>
-                <a:latin typeface="Pretendard"/>
-                <a:ea typeface="Pretendard"/>
-                <a:cs typeface="Pretendard"/>
+                <a:latin typeface="마루부리"/>
+                <a:ea typeface="마루부리"/>
+                <a:cs typeface="마루부리"/>
               </a:rPr>
               <a:t>얼리버드 유입 (오픈런)</a:t>
             </a:r>
@@ -8194,9 +8194,9 @@
                 <a:solidFill>
                   <a:srgbClr val="CCCCCC"/>
                 </a:solidFill>
-                <a:latin typeface="Pretendard"/>
-                <a:ea typeface="Pretendard"/>
-                <a:cs typeface="Pretendard"/>
+                <a:latin typeface="마루부리"/>
+                <a:ea typeface="마루부리"/>
+                <a:cs typeface="마루부리"/>
               </a:rPr>
               <a:t>“다양한 인디 뷰티 본품 혜택과 다채로운 이벤트”라는 정보가 온라인 뷰티 커뮤니티·SNS로 확산되며 오전 11시 오픈 전부터 대기 수요 발생.</a:t>
             </a:r>
@@ -8277,9 +8277,9 @@
                 <a:solidFill>
                   <a:srgbClr val="FFFFFF"/>
                 </a:solidFill>
-                <a:latin typeface="Pretendard"/>
-                <a:ea typeface="Pretendard"/>
-                <a:cs typeface="Pretendard"/>
+                <a:latin typeface="마루부리"/>
+                <a:ea typeface="마루부리"/>
+                <a:cs typeface="마루부리"/>
               </a:rPr>
               <a:t>공유 가치가 있는 굿즈</a:t>
             </a:r>
@@ -8318,9 +8318,9 @@
                 <a:solidFill>
                   <a:srgbClr val="CCCCCC"/>
                 </a:solidFill>
-                <a:latin typeface="Pretendard"/>
-                <a:ea typeface="Pretendard"/>
-                <a:cs typeface="Pretendard"/>
+                <a:latin typeface="마루부리"/>
+                <a:ea typeface="마루부리"/>
+                <a:cs typeface="마루부리"/>
               </a:rPr>
               <a:t>소장 가치 높은 티코스터와 세련된 스크런치 증정으로, 방문객이 자발적으로 #모에뜨 #성수팝업 인증샷을 업로드하도록 유도.</a:t>
             </a:r>
@@ -8458,9 +8458,9 @@
                 <a:solidFill>
                   <a:srgbClr val="CCCCCC"/>
                 </a:solidFill>
-                <a:latin typeface="Pretendard"/>
-                <a:ea typeface="Pretendard"/>
-                <a:cs typeface="Pretendard"/>
+                <a:latin typeface="마루부리"/>
+                <a:ea typeface="마루부리"/>
+                <a:cs typeface="마루부리"/>
               </a:rPr>
               <a:t>제품/현장 이미지</a:t>
             </a:r>
@@ -8476,9 +8476,9 @@
                 <a:solidFill>
                   <a:srgbClr val="CCCCCC"/>
                 </a:solidFill>
-                <a:latin typeface="Pretendard"/>
-                <a:ea typeface="Pretendard"/>
-                <a:cs typeface="Pretendard"/>
+                <a:latin typeface="마루부리"/>
+                <a:ea typeface="마루부리"/>
+                <a:cs typeface="마루부리"/>
               </a:rPr>
               <a:t/>
             </a:r>
@@ -8494,9 +8494,9 @@
                 <a:solidFill>
                   <a:srgbClr val="CCCCCC"/>
                 </a:solidFill>
-                <a:latin typeface="Pretendard"/>
-                <a:ea typeface="Pretendard"/>
-                <a:cs typeface="Pretendard"/>
+                <a:latin typeface="마루부리"/>
+                <a:ea typeface="마루부리"/>
+                <a:cs typeface="마루부리"/>
               </a:rPr>
               <a:t>인스타그램 피드 캡처 · 방문 인플루언서 인증샷 레이아웃</a:t>
             </a:r>
@@ -8531,9 +8531,9 @@
                 <a:solidFill>
                   <a:srgbClr val="CCCCCC"/>
                 </a:solidFill>
-                <a:latin typeface="Pretendard"/>
-                <a:ea typeface="Pretendard"/>
-                <a:cs typeface="Pretendard"/>
+                <a:latin typeface="마루부리"/>
+                <a:ea typeface="마루부리"/>
+                <a:cs typeface="마루부리"/>
               </a:rPr>
               <a:t>moét × ONVIEW · BEAUTY PLAYGROUND IN SEONGSU</a:t>
             </a:r>
@@ -8568,9 +8568,9 @@
                 <a:solidFill>
                   <a:srgbClr val="CCCCCC"/>
                 </a:solidFill>
-                <a:latin typeface="Pretendard"/>
-                <a:ea typeface="Pretendard"/>
-                <a:cs typeface="Pretendard"/>
+                <a:latin typeface="마루부리"/>
+                <a:ea typeface="마루부리"/>
+                <a:cs typeface="마루부리"/>
               </a:rPr>
               <a:t>07 / 09</a:t>
             </a:r>
@@ -8667,9 +8667,9 @@
                 <a:solidFill>
                   <a:srgbClr val="0066CC"/>
                 </a:solidFill>
-                <a:latin typeface="Pretendard"/>
-                <a:ea typeface="Pretendard"/>
-                <a:cs typeface="Pretendard"/>
+                <a:latin typeface="마루부리"/>
+                <a:ea typeface="마루부리"/>
+                <a:cs typeface="마루부리"/>
               </a:rPr>
               <a:t>06  INDUCEMENT</a:t>
             </a:r>
@@ -8704,9 +8704,9 @@
                 <a:solidFill>
                   <a:srgbClr val="1D1D1F"/>
                 </a:solidFill>
-                <a:latin typeface="Pretendard"/>
-                <a:ea typeface="Pretendard"/>
-                <a:cs typeface="Pretendard"/>
+                <a:latin typeface="마루부리"/>
+                <a:ea typeface="마루부리"/>
+                <a:cs typeface="마루부리"/>
               </a:rPr>
               <a:t>유도성</a:t>
             </a:r>
@@ -8745,9 +8745,9 @@
                 <a:solidFill>
                   <a:srgbClr val="7A7A7A"/>
                 </a:solidFill>
-                <a:latin typeface="Pretendard"/>
-                <a:ea typeface="Pretendard"/>
-                <a:cs typeface="Pretendard"/>
+                <a:latin typeface="마루부리"/>
+                <a:ea typeface="마루부리"/>
+                <a:cs typeface="마루부리"/>
               </a:rPr>
               <a:t>오프라인 구매 전환과 온라인 록인(Lock-in)의 연계</a:t>
             </a:r>
@@ -8830,9 +8830,9 @@
                 <a:solidFill>
                   <a:srgbClr val="1D1D1F"/>
                 </a:solidFill>
-                <a:latin typeface="Pretendard"/>
-                <a:ea typeface="Pretendard"/>
-                <a:cs typeface="Pretendard"/>
+                <a:latin typeface="마루부리"/>
+                <a:ea typeface="마루부리"/>
+                <a:cs typeface="마루부리"/>
               </a:rPr>
               <a:t>즉각적 구매 동기부여</a:t>
             </a:r>
@@ -8871,9 +8871,9 @@
                 <a:solidFill>
                   <a:srgbClr val="333333"/>
                 </a:solidFill>
-                <a:latin typeface="Pretendard"/>
-                <a:ea typeface="Pretendard"/>
-                <a:cs typeface="Pretendard"/>
+                <a:latin typeface="마루부리"/>
+                <a:ea typeface="마루부리"/>
+                <a:cs typeface="마루부리"/>
               </a:rPr>
               <a:t>전 제품 50%~최대 58% 파격 팝업 한정 할인가로 가격 장벽을 무너뜨려 현장 구매를 강력히 유도.</a:t>
             </a:r>
@@ -8956,9 +8956,9 @@
                 <a:solidFill>
                   <a:srgbClr val="1D1D1F"/>
                 </a:solidFill>
-                <a:latin typeface="Pretendard"/>
-                <a:ea typeface="Pretendard"/>
-                <a:cs typeface="Pretendard"/>
+                <a:latin typeface="마루부리"/>
+                <a:ea typeface="마루부리"/>
+                <a:cs typeface="마루부리"/>
               </a:rPr>
               <a:t>구매 넛지(Nudge) 설계</a:t>
             </a:r>
@@ -8997,9 +8997,9 @@
                 <a:solidFill>
                   <a:srgbClr val="333333"/>
                 </a:solidFill>
-                <a:latin typeface="Pretendard"/>
-                <a:ea typeface="Pretendard"/>
-                <a:cs typeface="Pretendard"/>
+                <a:latin typeface="마루부리"/>
+                <a:ea typeface="마루부리"/>
+                <a:cs typeface="마루부리"/>
               </a:rPr>
               <a:t>‘1개 구매 시 티코스터, 2개 이상 구매 시 스크런치 추가’ 단계별 사은품으로 자연스러운 객단가 상승 유도.</a:t>
             </a:r>
@@ -9128,9 +9128,9 @@
                 <a:solidFill>
                   <a:srgbClr val="1D1D1F"/>
                 </a:solidFill>
-                <a:latin typeface="Pretendard"/>
-                <a:ea typeface="Pretendard"/>
-                <a:cs typeface="Pretendard"/>
+                <a:latin typeface="마루부리"/>
+                <a:ea typeface="마루부리"/>
+                <a:cs typeface="마루부리"/>
               </a:rPr>
               <a:t>온라인 재유입 전략</a:t>
             </a:r>
@@ -9169,9 +9169,9 @@
                 <a:solidFill>
                   <a:srgbClr val="333333"/>
                 </a:solidFill>
-                <a:latin typeface="Pretendard"/>
-                <a:ea typeface="Pretendard"/>
-                <a:cs typeface="Pretendard"/>
+                <a:latin typeface="마루부리"/>
+                <a:ea typeface="마루부리"/>
+                <a:cs typeface="마루부리"/>
               </a:rPr>
               <a:t>럭키드로우 상품으로 ‘자사몰 1만원 할인 쿠폰’을 설계, 팝업 종료 후에도 온라인 채널로 지속 유입되는 록인 장치 마련.</a:t>
             </a:r>
@@ -9252,9 +9252,9 @@
                 <a:solidFill>
                   <a:srgbClr val="7A7A7A"/>
                 </a:solidFill>
-                <a:latin typeface="Pretendard"/>
-                <a:ea typeface="Pretendard"/>
-                <a:cs typeface="Pretendard"/>
+                <a:latin typeface="마루부리"/>
+                <a:ea typeface="마루부리"/>
+                <a:cs typeface="마루부리"/>
               </a:rPr>
               <a:t>팝업 한정 할인율</a:t>
             </a:r>
@@ -9289,9 +9289,9 @@
                 <a:solidFill>
                   <a:srgbClr val="1D1D1F"/>
                 </a:solidFill>
-                <a:latin typeface="Pretendard"/>
-                <a:ea typeface="Pretendard"/>
-                <a:cs typeface="Pretendard"/>
+                <a:latin typeface="마루부리"/>
+                <a:ea typeface="마루부리"/>
+                <a:cs typeface="마루부리"/>
               </a:rPr>
               <a:t>50–58</a:t>
             </a:r>
@@ -9303,9 +9303,9 @@
                 <a:solidFill>
                   <a:srgbClr val="0066CC"/>
                 </a:solidFill>
-                <a:latin typeface="Pretendard"/>
-                <a:ea typeface="Pretendard"/>
-                <a:cs typeface="Pretendard"/>
+                <a:latin typeface="마루부리"/>
+                <a:ea typeface="마루부리"/>
+                <a:cs typeface="마루부리"/>
               </a:rPr>
               <a:t>%</a:t>
             </a:r>
@@ -9340,9 +9340,9 @@
                 <a:solidFill>
                   <a:srgbClr val="7A7A7A"/>
                 </a:solidFill>
-                <a:latin typeface="Pretendard"/>
-                <a:ea typeface="Pretendard"/>
-                <a:cs typeface="Pretendard"/>
+                <a:latin typeface="마루부리"/>
+                <a:ea typeface="마루부리"/>
+                <a:cs typeface="마루부리"/>
               </a:rPr>
               <a:t>전 제품 기준 최대 할인 · 현장 구매 전환 극대화</a:t>
             </a:r>
@@ -9480,9 +9480,9 @@
                 <a:solidFill>
                   <a:srgbClr val="7A7A7A"/>
                 </a:solidFill>
-                <a:latin typeface="Pretendard"/>
-                <a:ea typeface="Pretendard"/>
-                <a:cs typeface="Pretendard"/>
+                <a:latin typeface="마루부리"/>
+                <a:ea typeface="마루부리"/>
+                <a:cs typeface="마루부리"/>
               </a:rPr>
               <a:t>제품/현장 이미지</a:t>
             </a:r>
@@ -9498,9 +9498,9 @@
                 <a:solidFill>
                   <a:srgbClr val="7A7A7A"/>
                 </a:solidFill>
-                <a:latin typeface="Pretendard"/>
-                <a:ea typeface="Pretendard"/>
-                <a:cs typeface="Pretendard"/>
+                <a:latin typeface="마루부리"/>
+                <a:ea typeface="마루부리"/>
+                <a:cs typeface="마루부리"/>
               </a:rPr>
               <a:t/>
             </a:r>
@@ -9516,9 +9516,9 @@
                 <a:solidFill>
                   <a:srgbClr val="7A7A7A"/>
                 </a:solidFill>
-                <a:latin typeface="Pretendard"/>
-                <a:ea typeface="Pretendard"/>
-                <a:cs typeface="Pretendard"/>
+                <a:latin typeface="마루부리"/>
+                <a:ea typeface="마루부리"/>
+                <a:cs typeface="마루부리"/>
               </a:rPr>
               <a:t>샴푸·티코스터·스크런치 언박싱 컷</a:t>
             </a:r>
@@ -9553,9 +9553,9 @@
                 <a:solidFill>
                   <a:srgbClr val="7A7A7A"/>
                 </a:solidFill>
-                <a:latin typeface="Pretendard"/>
-                <a:ea typeface="Pretendard"/>
-                <a:cs typeface="Pretendard"/>
+                <a:latin typeface="마루부리"/>
+                <a:ea typeface="마루부리"/>
+                <a:cs typeface="마루부리"/>
               </a:rPr>
               <a:t>moét × ONVIEW · BEAUTY PLAYGROUND IN SEONGSU</a:t>
             </a:r>
@@ -9590,9 +9590,9 @@
                 <a:solidFill>
                   <a:srgbClr val="7A7A7A"/>
                 </a:solidFill>
-                <a:latin typeface="Pretendard"/>
-                <a:ea typeface="Pretendard"/>
-                <a:cs typeface="Pretendard"/>
+                <a:latin typeface="마루부리"/>
+                <a:ea typeface="마루부리"/>
+                <a:cs typeface="마루부리"/>
               </a:rPr>
               <a:t>08 / 09</a:t>
             </a:r>
@@ -9689,9 +9689,9 @@
                 <a:solidFill>
                   <a:srgbClr val="2997FF"/>
                 </a:solidFill>
-                <a:latin typeface="Pretendard"/>
-                <a:ea typeface="Pretendard"/>
-                <a:cs typeface="Pretendard"/>
+                <a:latin typeface="마루부리"/>
+                <a:ea typeface="마루부리"/>
+                <a:cs typeface="마루부리"/>
               </a:rPr>
               <a:t>CONCLUSION</a:t>
             </a:r>
@@ -9726,9 +9726,9 @@
                 <a:solidFill>
                   <a:srgbClr val="FFFFFF"/>
                 </a:solidFill>
-                <a:latin typeface="Pretendard"/>
-                <a:ea typeface="Pretendard"/>
-                <a:cs typeface="Pretendard"/>
+                <a:latin typeface="마루부리"/>
+                <a:ea typeface="마루부리"/>
+                <a:cs typeface="마루부리"/>
               </a:rPr>
               <a:t>결론 및 종합 의견</a:t>
             </a:r>
@@ -9763,9 +9763,9 @@
                 <a:solidFill>
                   <a:srgbClr val="CCCCCC"/>
                 </a:solidFill>
-                <a:latin typeface="Pretendard"/>
-                <a:ea typeface="Pretendard"/>
-                <a:cs typeface="Pretendard"/>
+                <a:latin typeface="마루부리"/>
+                <a:ea typeface="마루부리"/>
+                <a:cs typeface="마루부리"/>
               </a:rPr>
               <a:t>직접 체험하며 느낀 점 및 총평</a:t>
             </a:r>
@@ -9882,9 +9882,9 @@
                 <a:solidFill>
                   <a:srgbClr val="2997FF"/>
                 </a:solidFill>
-                <a:latin typeface="Pretendard"/>
-                <a:ea typeface="Pretendard"/>
-                <a:cs typeface="Pretendard"/>
+                <a:latin typeface="마루부리"/>
+                <a:ea typeface="마루부리"/>
+                <a:cs typeface="마루부리"/>
               </a:rPr>
               <a:t>“</a:t>
             </a:r>
@@ -9923,9 +9923,9 @@
                 <a:solidFill>
                   <a:srgbClr val="FFFFFF"/>
                 </a:solidFill>
-                <a:latin typeface="Pretendard"/>
-                <a:ea typeface="Pretendard"/>
-                <a:cs typeface="Pretendard"/>
+                <a:latin typeface="마루부리"/>
+                <a:ea typeface="마루부리"/>
+                <a:cs typeface="마루부리"/>
               </a:rPr>
               <a:t>외부 자극·스트레스로 두피 고민이 많던 소비자 입장에서 매우 만족스러운 경험. 기능성 탈모 샴푸는 향이 딱딱하고 모발이 뻣뻣해진다는 편견이 있었으나, ‘풍성한 거품·찰랑이는 머릿결·세련된 머스크 향’으로 오프라인 체험이 준 신뢰감을 그대로 이어감.</a:t>
             </a:r>
@@ -10056,9 +10056,9 @@
                 <a:solidFill>
                   <a:srgbClr val="FFFFFF"/>
                 </a:solidFill>
-                <a:latin typeface="Pretendard"/>
-                <a:ea typeface="Pretendard"/>
-                <a:cs typeface="Pretendard"/>
+                <a:latin typeface="마루부리"/>
+                <a:ea typeface="마루부리"/>
+                <a:cs typeface="마루부리"/>
               </a:rPr>
               <a:t>화려한 마케팅 수식어 대신 제품의 본질(Pure Origin)을 강조하고, 이를 성수동이라는 감각적 오프라인 공간 안에서 영리한 혜택 체계(Real Change)로 풀어냄.  </a:t>
             </a:r>
@@ -10074,9 +10074,9 @@
                 <a:solidFill>
                   <a:srgbClr val="2997FF"/>
                 </a:solidFill>
-                <a:latin typeface="Pretendard"/>
-                <a:ea typeface="Pretendard"/>
-                <a:cs typeface="Pretendard"/>
+                <a:latin typeface="마루부리"/>
+                <a:ea typeface="마루부리"/>
+                <a:cs typeface="마루부리"/>
               </a:rPr>
               <a:t>인디 브랜드가 고객 접점을 극대화한 훌륭한 리테일 전략 사례.</a:t>
             </a:r>
@@ -10111,9 +10111,9 @@
                 <a:solidFill>
                   <a:srgbClr val="CCCCCC"/>
                 </a:solidFill>
-                <a:latin typeface="Pretendard"/>
-                <a:ea typeface="Pretendard"/>
-                <a:cs typeface="Pretendard"/>
+                <a:latin typeface="마루부리"/>
+                <a:ea typeface="마루부리"/>
+                <a:cs typeface="마루부리"/>
               </a:rPr>
               <a:t>Pure Origin, Real Change</a:t>
             </a:r>
@@ -10148,9 +10148,9 @@
                 <a:solidFill>
                   <a:srgbClr val="CCCCCC"/>
                 </a:solidFill>
-                <a:latin typeface="Pretendard"/>
-                <a:ea typeface="Pretendard"/>
-                <a:cs typeface="Pretendard"/>
+                <a:latin typeface="마루부리"/>
+                <a:ea typeface="마루부리"/>
+                <a:cs typeface="마루부리"/>
               </a:rPr>
               <a:t>moét × ONVIEW · BEAUTY PLAYGROUND IN SEONGSU</a:t>
             </a:r>
@@ -10185,9 +10185,9 @@
                 <a:solidFill>
                   <a:srgbClr val="CCCCCC"/>
                 </a:solidFill>
-                <a:latin typeface="Pretendard"/>
-                <a:ea typeface="Pretendard"/>
-                <a:cs typeface="Pretendard"/>
+                <a:latin typeface="마루부리"/>
+                <a:ea typeface="마루부리"/>
+                <a:cs typeface="마루부리"/>
               </a:rPr>
               <a:t>09 / 09</a:t>
             </a:r>

</xml_diff>

<commit_message>
Switch deck font back to Pretendard
</commit_message>
<xml_diff>
--- a/moet_onview_popup_report_apple.pptx
+++ b/moet_onview_popup_report_apple.pptx
@@ -3168,9 +3168,9 @@
                 <a:solidFill>
                   <a:srgbClr val="0066CC"/>
                 </a:solidFill>
-                <a:latin typeface="마루부리"/>
-                <a:ea typeface="마루부리"/>
-                <a:cs typeface="마루부리"/>
+                <a:latin typeface="Pretendard"/>
+                <a:ea typeface="Pretendard"/>
+                <a:cs typeface="Pretendard"/>
               </a:rPr>
               <a:t>팝업 리테일 공간 분석 보고서</a:t>
             </a:r>
@@ -3205,9 +3205,9 @@
                 <a:solidFill>
                   <a:srgbClr val="0066CC"/>
                 </a:solidFill>
-                <a:latin typeface="마루부리"/>
-                <a:ea typeface="마루부리"/>
-                <a:cs typeface="마루부리"/>
+                <a:latin typeface="Pretendard"/>
+                <a:ea typeface="Pretendard"/>
+                <a:cs typeface="Pretendard"/>
               </a:rPr>
               <a:t>팝업 리테일 공간 분석 보고서</a:t>
             </a:r>
@@ -3246,9 +3246,9 @@
                 <a:solidFill>
                   <a:srgbClr val="1D1D1F"/>
                 </a:solidFill>
-                <a:latin typeface="마루부리"/>
-                <a:ea typeface="마루부리"/>
-                <a:cs typeface="마루부리"/>
+                <a:latin typeface="Pretendard"/>
+                <a:ea typeface="Pretendard"/>
+                <a:cs typeface="Pretendard"/>
               </a:rPr>
               <a:t>BEAUTY PLAYGROUND</a:t>
             </a:r>
@@ -3264,9 +3264,9 @@
                 <a:solidFill>
                   <a:srgbClr val="1D1D1F"/>
                 </a:solidFill>
-                <a:latin typeface="마루부리"/>
-                <a:ea typeface="마루부리"/>
-                <a:cs typeface="마루부리"/>
+                <a:latin typeface="Pretendard"/>
+                <a:ea typeface="Pretendard"/>
+                <a:cs typeface="Pretendard"/>
               </a:rPr>
               <a:t>IN SEONGSU</a:t>
             </a:r>
@@ -3305,9 +3305,9 @@
                 <a:solidFill>
                   <a:srgbClr val="333333"/>
                 </a:solidFill>
-                <a:latin typeface="마루부리"/>
-                <a:ea typeface="마루부리"/>
-                <a:cs typeface="마루부리"/>
+                <a:latin typeface="Pretendard"/>
+                <a:ea typeface="Pretendard"/>
+                <a:cs typeface="Pretendard"/>
               </a:rPr>
               <a:t>리테일 공간 팝업스토어 분석 보고서</a:t>
             </a:r>
@@ -3323,9 +3323,9 @@
                 <a:solidFill>
                   <a:srgbClr val="7A7A7A"/>
                 </a:solidFill>
-                <a:latin typeface="마루부리"/>
-                <a:ea typeface="마루부리"/>
-                <a:cs typeface="마루부리"/>
+                <a:latin typeface="Pretendard"/>
+                <a:ea typeface="Pretendard"/>
+                <a:cs typeface="Pretendard"/>
               </a:rPr>
               <a:t/>
             </a:r>
@@ -3341,9 +3341,9 @@
                 <a:solidFill>
                   <a:srgbClr val="7A7A7A"/>
                 </a:solidFill>
-                <a:latin typeface="마루부리"/>
-                <a:ea typeface="마루부리"/>
-                <a:cs typeface="마루부리"/>
+                <a:latin typeface="Pretendard"/>
+                <a:ea typeface="Pretendard"/>
+                <a:cs typeface="Pretendard"/>
               </a:rPr>
               <a:t>모에뜨(moét) 브랜드존 중심  ·  moét × ONVIEW</a:t>
             </a:r>
@@ -3424,9 +3424,9 @@
                 <a:solidFill>
                   <a:srgbClr val="FFFFFF"/>
                 </a:solidFill>
-                <a:latin typeface="마루부리"/>
-                <a:ea typeface="마루부리"/>
-                <a:cs typeface="마루부리"/>
+                <a:latin typeface="Pretendard"/>
+                <a:ea typeface="Pretendard"/>
+                <a:cs typeface="Pretendard"/>
               </a:rPr>
               <a:t>분석 개요</a:t>
             </a:r>
@@ -3507,9 +3507,9 @@
                 <a:solidFill>
                   <a:srgbClr val="0066CC"/>
                 </a:solidFill>
-                <a:latin typeface="마루부리"/>
-                <a:ea typeface="마루부리"/>
-                <a:cs typeface="마루부리"/>
+                <a:latin typeface="Pretendard"/>
+                <a:ea typeface="Pretendard"/>
+                <a:cs typeface="Pretendard"/>
               </a:rPr>
               <a:t>종합 의견</a:t>
             </a:r>
@@ -3580,9 +3580,9 @@
                 <a:solidFill>
                   <a:srgbClr val="7A7A7A"/>
                 </a:solidFill>
-                <a:latin typeface="마루부리"/>
-                <a:ea typeface="마루부리"/>
-                <a:cs typeface="마루부리"/>
+                <a:latin typeface="Pretendard"/>
+                <a:ea typeface="Pretendard"/>
+                <a:cs typeface="Pretendard"/>
               </a:rPr>
               <a:t>14주차 과제 레포트   ·   과목명 _______   ·   학번 _______   ·   이름 _______</a:t>
             </a:r>
@@ -3679,9 +3679,9 @@
                 <a:solidFill>
                   <a:srgbClr val="0066CC"/>
                 </a:solidFill>
-                <a:latin typeface="마루부리"/>
-                <a:ea typeface="마루부리"/>
-                <a:cs typeface="마루부리"/>
+                <a:latin typeface="Pretendard"/>
+                <a:ea typeface="Pretendard"/>
+                <a:cs typeface="Pretendard"/>
               </a:rPr>
               <a:t>OVERVIEW</a:t>
             </a:r>
@@ -3716,9 +3716,9 @@
                 <a:solidFill>
                   <a:srgbClr val="1D1D1F"/>
                 </a:solidFill>
-                <a:latin typeface="마루부리"/>
-                <a:ea typeface="마루부리"/>
-                <a:cs typeface="마루부리"/>
+                <a:latin typeface="Pretendard"/>
+                <a:ea typeface="Pretendard"/>
+                <a:cs typeface="Pretendard"/>
               </a:rPr>
               <a:t>개요</a:t>
             </a:r>
@@ -3789,9 +3789,9 @@
                 <a:solidFill>
                   <a:srgbClr val="0066CC"/>
                 </a:solidFill>
-                <a:latin typeface="마루부리"/>
-                <a:ea typeface="마루부리"/>
-                <a:cs typeface="마루부리"/>
+                <a:latin typeface="Pretendard"/>
+                <a:ea typeface="Pretendard"/>
+                <a:cs typeface="Pretendard"/>
               </a:rPr>
               <a:t>WHAT</a:t>
             </a:r>
@@ -3830,9 +3830,9 @@
                 <a:solidFill>
                   <a:srgbClr val="333333"/>
                 </a:solidFill>
-                <a:latin typeface="마루부리"/>
-                <a:ea typeface="마루부리"/>
-                <a:cs typeface="마루부리"/>
+                <a:latin typeface="Pretendard"/>
+                <a:ea typeface="Pretendard"/>
+                <a:cs typeface="Pretendard"/>
               </a:rPr>
               <a:t>성수동 중심가에서 개최된 인디 뷰티 큐레이션 플랫폼 ‘오엔뷰(ONVIEW)’와 모에뜨의 협업 팝업스토어. K-뷰티 고관여 MZ세대를 타깃으로, 일시적 제품 판매를 넘어 오감 체험(시향·제형)과 팝업 한정 리워드를 제공하는 ‘경험형 리테일 매장’으로 기획되었음.</a:t>
             </a:r>
@@ -3919,9 +3919,9 @@
                 <a:solidFill>
                   <a:srgbClr val="0066CC"/>
                 </a:solidFill>
-                <a:latin typeface="마루부리"/>
-                <a:ea typeface="마루부리"/>
-                <a:cs typeface="마루부리"/>
+                <a:latin typeface="Pretendard"/>
+                <a:ea typeface="Pretendard"/>
+                <a:cs typeface="Pretendard"/>
               </a:rPr>
               <a:t>운영 유의</a:t>
             </a:r>
@@ -3937,9 +3937,9 @@
                 <a:solidFill>
                   <a:srgbClr val="1D1D1F"/>
                 </a:solidFill>
-                <a:latin typeface="마루부리"/>
-                <a:ea typeface="마루부리"/>
-                <a:cs typeface="마루부리"/>
+                <a:latin typeface="Pretendard"/>
+                <a:ea typeface="Pretendard"/>
+                <a:cs typeface="Pretendard"/>
               </a:rPr>
               <a:t/>
             </a:r>
@@ -3955,9 +3955,9 @@
                 <a:solidFill>
                   <a:srgbClr val="1D1D1F"/>
                 </a:solidFill>
-                <a:latin typeface="마루부리"/>
-                <a:ea typeface="마루부리"/>
-                <a:cs typeface="마루부리"/>
+                <a:latin typeface="Pretendard"/>
+                <a:ea typeface="Pretendard"/>
+                <a:cs typeface="Pretendard"/>
               </a:rPr>
               <a:t>모에뜨 브랜드존은 6월 4일(목)까지만 조기 운영</a:t>
             </a:r>
@@ -4040,9 +4040,9 @@
                 <a:solidFill>
                   <a:srgbClr val="7A7A7A"/>
                 </a:solidFill>
-                <a:latin typeface="마루부리"/>
-                <a:ea typeface="마루부리"/>
-                <a:cs typeface="마루부리"/>
+                <a:latin typeface="Pretendard"/>
+                <a:ea typeface="Pretendard"/>
+                <a:cs typeface="Pretendard"/>
               </a:rPr>
               <a:t>브랜드</a:t>
             </a:r>
@@ -4081,9 +4081,9 @@
                 <a:solidFill>
                   <a:srgbClr val="1D1D1F"/>
                 </a:solidFill>
-                <a:latin typeface="마루부리"/>
-                <a:ea typeface="마루부리"/>
-                <a:cs typeface="마루부리"/>
+                <a:latin typeface="Pretendard"/>
+                <a:ea typeface="Pretendard"/>
+                <a:cs typeface="Pretendard"/>
               </a:rPr>
               <a:t>모에뜨 (moét)</a:t>
             </a:r>
@@ -4154,9 +4154,9 @@
                 <a:solidFill>
                   <a:srgbClr val="7A7A7A"/>
                 </a:solidFill>
-                <a:latin typeface="마루부리"/>
-                <a:ea typeface="마루부리"/>
-                <a:cs typeface="마루부리"/>
+                <a:latin typeface="Pretendard"/>
+                <a:ea typeface="Pretendard"/>
+                <a:cs typeface="Pretendard"/>
               </a:rPr>
               <a:t>팝업스토어명</a:t>
             </a:r>
@@ -4195,9 +4195,9 @@
                 <a:solidFill>
                   <a:srgbClr val="1D1D1F"/>
                 </a:solidFill>
-                <a:latin typeface="마루부리"/>
-                <a:ea typeface="마루부리"/>
-                <a:cs typeface="마루부리"/>
+                <a:latin typeface="Pretendard"/>
+                <a:ea typeface="Pretendard"/>
+                <a:cs typeface="Pretendard"/>
               </a:rPr>
               <a:t>BEAUTY PLAYGROUND IN SEONGSU</a:t>
             </a:r>
@@ -4268,9 +4268,9 @@
                 <a:solidFill>
                   <a:srgbClr val="7A7A7A"/>
                 </a:solidFill>
-                <a:latin typeface="마루부리"/>
-                <a:ea typeface="마루부리"/>
-                <a:cs typeface="마루부리"/>
+                <a:latin typeface="Pretendard"/>
+                <a:ea typeface="Pretendard"/>
+                <a:cs typeface="Pretendard"/>
               </a:rPr>
               <a:t>행사 기간</a:t>
             </a:r>
@@ -4309,9 +4309,9 @@
                 <a:solidFill>
                   <a:srgbClr val="1D1D1F"/>
                 </a:solidFill>
-                <a:latin typeface="마루부리"/>
-                <a:ea typeface="마루부리"/>
-                <a:cs typeface="마루부리"/>
+                <a:latin typeface="Pretendard"/>
+                <a:ea typeface="Pretendard"/>
+                <a:cs typeface="Pretendard"/>
               </a:rPr>
               <a:t>2026.05.22(금) ~ 06.10(수)</a:t>
             </a:r>
@@ -4382,9 +4382,9 @@
                 <a:solidFill>
                   <a:srgbClr val="7A7A7A"/>
                 </a:solidFill>
-                <a:latin typeface="마루부리"/>
-                <a:ea typeface="마루부리"/>
-                <a:cs typeface="마루부리"/>
+                <a:latin typeface="Pretendard"/>
+                <a:ea typeface="Pretendard"/>
+                <a:cs typeface="Pretendard"/>
               </a:rPr>
               <a:t>운영 시간</a:t>
             </a:r>
@@ -4423,9 +4423,9 @@
                 <a:solidFill>
                   <a:srgbClr val="1D1D1F"/>
                 </a:solidFill>
-                <a:latin typeface="마루부리"/>
-                <a:ea typeface="마루부리"/>
-                <a:cs typeface="마루부리"/>
+                <a:latin typeface="Pretendard"/>
+                <a:ea typeface="Pretendard"/>
+                <a:cs typeface="Pretendard"/>
               </a:rPr>
               <a:t>11:00 ~ 19:00 (입장 마감 18:30)</a:t>
             </a:r>
@@ -4496,9 +4496,9 @@
                 <a:solidFill>
                   <a:srgbClr val="7A7A7A"/>
                 </a:solidFill>
-                <a:latin typeface="마루부리"/>
-                <a:ea typeface="마루부리"/>
-                <a:cs typeface="마루부리"/>
+                <a:latin typeface="Pretendard"/>
+                <a:ea typeface="Pretendard"/>
+                <a:cs typeface="Pretendard"/>
               </a:rPr>
               <a:t>장소</a:t>
             </a:r>
@@ -4537,9 +4537,9 @@
                 <a:solidFill>
                   <a:srgbClr val="1D1D1F"/>
                 </a:solidFill>
-                <a:latin typeface="마루부리"/>
-                <a:ea typeface="마루부리"/>
-                <a:cs typeface="마루부리"/>
+                <a:latin typeface="Pretendard"/>
+                <a:ea typeface="Pretendard"/>
+                <a:cs typeface="Pretendard"/>
               </a:rPr>
               <a:t>맵달SEOUL 성수 3F</a:t>
             </a:r>
@@ -4555,9 +4555,9 @@
                 <a:solidFill>
                   <a:srgbClr val="1D1D1F"/>
                 </a:solidFill>
-                <a:latin typeface="마루부리"/>
-                <a:ea typeface="마루부리"/>
-                <a:cs typeface="마루부리"/>
+                <a:latin typeface="Pretendard"/>
+                <a:ea typeface="Pretendard"/>
+                <a:cs typeface="Pretendard"/>
               </a:rPr>
               <a:t>성동구 성수이로16길 5</a:t>
             </a:r>
@@ -4592,9 +4592,9 @@
                 <a:solidFill>
                   <a:srgbClr val="7A7A7A"/>
                 </a:solidFill>
-                <a:latin typeface="마루부리"/>
-                <a:ea typeface="마루부리"/>
-                <a:cs typeface="마루부리"/>
+                <a:latin typeface="Pretendard"/>
+                <a:ea typeface="Pretendard"/>
+                <a:cs typeface="Pretendard"/>
               </a:rPr>
               <a:t>moét × ONVIEW · BEAUTY PLAYGROUND IN SEONGSU</a:t>
             </a:r>
@@ -4629,9 +4629,9 @@
                 <a:solidFill>
                   <a:srgbClr val="7A7A7A"/>
                 </a:solidFill>
-                <a:latin typeface="마루부리"/>
-                <a:ea typeface="마루부리"/>
-                <a:cs typeface="마루부리"/>
+                <a:latin typeface="Pretendard"/>
+                <a:ea typeface="Pretendard"/>
+                <a:cs typeface="Pretendard"/>
               </a:rPr>
               <a:t>02 / 09</a:t>
             </a:r>
@@ -4728,9 +4728,9 @@
                 <a:solidFill>
                   <a:srgbClr val="2997FF"/>
                 </a:solidFill>
-                <a:latin typeface="마루부리"/>
-                <a:ea typeface="마루부리"/>
-                <a:cs typeface="마루부리"/>
+                <a:latin typeface="Pretendard"/>
+                <a:ea typeface="Pretendard"/>
+                <a:cs typeface="Pretendard"/>
               </a:rPr>
               <a:t>01  LOCALITY</a:t>
             </a:r>
@@ -4765,9 +4765,9 @@
                 <a:solidFill>
                   <a:srgbClr val="FFFFFF"/>
                 </a:solidFill>
-                <a:latin typeface="마루부리"/>
-                <a:ea typeface="마루부리"/>
-                <a:cs typeface="마루부리"/>
+                <a:latin typeface="Pretendard"/>
+                <a:ea typeface="Pretendard"/>
+                <a:cs typeface="Pretendard"/>
               </a:rPr>
               <a:t>장소성</a:t>
             </a:r>
@@ -4806,9 +4806,9 @@
                 <a:solidFill>
                   <a:srgbClr val="CCCCCC"/>
                 </a:solidFill>
-                <a:latin typeface="마루부리"/>
-                <a:ea typeface="마루부리"/>
-                <a:cs typeface="마루부리"/>
+                <a:latin typeface="Pretendard"/>
+                <a:ea typeface="Pretendard"/>
+                <a:cs typeface="Pretendard"/>
               </a:rPr>
               <a:t>트렌드세터의 중심지, 성수동 상권과의 유기적 결합</a:t>
             </a:r>
@@ -4935,9 +4935,9 @@
                 <a:solidFill>
                   <a:srgbClr val="FFFFFF"/>
                 </a:solidFill>
-                <a:latin typeface="마루부리"/>
-                <a:ea typeface="마루부리"/>
-                <a:cs typeface="마루부리"/>
+                <a:latin typeface="Pretendard"/>
+                <a:ea typeface="Pretendard"/>
+                <a:cs typeface="Pretendard"/>
               </a:rPr>
               <a:t>트렌디한 소비층 밀집</a:t>
             </a:r>
@@ -4976,9 +4976,9 @@
                 <a:solidFill>
                   <a:srgbClr val="CCCCCC"/>
                 </a:solidFill>
-                <a:latin typeface="마루부리"/>
-                <a:ea typeface="마루부리"/>
-                <a:cs typeface="마루부리"/>
+                <a:latin typeface="Pretendard"/>
+                <a:ea typeface="Pretendard"/>
+                <a:cs typeface="Pretendard"/>
               </a:rPr>
               <a:t>국내외 MZ세대 및 K-뷰티 고관여 소비자가 가장 활발하게 유입되는 서울 성수동 중심 상권에 위치.</a:t>
             </a:r>
@@ -5059,9 +5059,9 @@
                 <a:solidFill>
                   <a:srgbClr val="FFFFFF"/>
                 </a:solidFill>
-                <a:latin typeface="마루부리"/>
-                <a:ea typeface="마루부리"/>
-                <a:cs typeface="마루부리"/>
+                <a:latin typeface="Pretendard"/>
+                <a:ea typeface="Pretendard"/>
+                <a:cs typeface="Pretendard"/>
               </a:rPr>
               <a:t>우수한 접근성</a:t>
             </a:r>
@@ -5100,9 +5100,9 @@
                 <a:solidFill>
                   <a:srgbClr val="CCCCCC"/>
                 </a:solidFill>
-                <a:latin typeface="마루부리"/>
-                <a:ea typeface="마루부리"/>
-                <a:cs typeface="마루부리"/>
+                <a:latin typeface="Pretendard"/>
+                <a:ea typeface="Pretendard"/>
+                <a:cs typeface="Pretendard"/>
               </a:rPr>
               <a:t>성수역 3번 출구에서 도보 5분 거리에 위치해 자연스러운 도보 방문객 유입률 확보.</a:t>
             </a:r>
@@ -5183,9 +5183,9 @@
                 <a:solidFill>
                   <a:srgbClr val="FFFFFF"/>
                 </a:solidFill>
-                <a:latin typeface="마루부리"/>
-                <a:ea typeface="마루부리"/>
-                <a:cs typeface="마루부리"/>
+                <a:latin typeface="Pretendard"/>
+                <a:ea typeface="Pretendard"/>
+                <a:cs typeface="Pretendard"/>
               </a:rPr>
               <a:t>공간의 적합성</a:t>
             </a:r>
@@ -5224,9 +5224,9 @@
                 <a:solidFill>
                   <a:srgbClr val="CCCCCC"/>
                 </a:solidFill>
-                <a:latin typeface="마루부리"/>
-                <a:ea typeface="마루부리"/>
-                <a:cs typeface="마루부리"/>
+                <a:latin typeface="Pretendard"/>
+                <a:ea typeface="Pretendard"/>
+                <a:cs typeface="Pretendard"/>
               </a:rPr>
               <a:t>‘맵달서울’ 3층을 활용, 대형 채널에서 못 보던 신선한 인디 뷰티를 발굴·체험하는 성수동 특유의 감성과 시너지.</a:t>
             </a:r>
@@ -5364,9 +5364,9 @@
                 <a:solidFill>
                   <a:srgbClr val="CCCCCC"/>
                 </a:solidFill>
-                <a:latin typeface="마루부리"/>
-                <a:ea typeface="마루부리"/>
-                <a:cs typeface="마루부리"/>
+                <a:latin typeface="Pretendard"/>
+                <a:ea typeface="Pretendard"/>
+                <a:cs typeface="Pretendard"/>
               </a:rPr>
               <a:t>제품/현장 이미지</a:t>
             </a:r>
@@ -5382,9 +5382,9 @@
                 <a:solidFill>
                   <a:srgbClr val="CCCCCC"/>
                 </a:solidFill>
-                <a:latin typeface="마루부리"/>
-                <a:ea typeface="마루부리"/>
-                <a:cs typeface="마루부리"/>
+                <a:latin typeface="Pretendard"/>
+                <a:ea typeface="Pretendard"/>
+                <a:cs typeface="Pretendard"/>
               </a:rPr>
               <a:t/>
             </a:r>
@@ -5400,9 +5400,9 @@
                 <a:solidFill>
                   <a:srgbClr val="CCCCCC"/>
                 </a:solidFill>
-                <a:latin typeface="마루부리"/>
-                <a:ea typeface="마루부리"/>
-                <a:cs typeface="마루부리"/>
+                <a:latin typeface="Pretendard"/>
+                <a:ea typeface="Pretendard"/>
+                <a:cs typeface="Pretendard"/>
               </a:rPr>
               <a:t>3층 행사장 진입 복도 및 입구 대기 줄</a:t>
             </a:r>
@@ -5437,9 +5437,9 @@
                 <a:solidFill>
                   <a:srgbClr val="CCCCCC"/>
                 </a:solidFill>
-                <a:latin typeface="마루부리"/>
-                <a:ea typeface="마루부리"/>
-                <a:cs typeface="마루부리"/>
+                <a:latin typeface="Pretendard"/>
+                <a:ea typeface="Pretendard"/>
+                <a:cs typeface="Pretendard"/>
               </a:rPr>
               <a:t>moét × ONVIEW · BEAUTY PLAYGROUND IN SEONGSU</a:t>
             </a:r>
@@ -5474,9 +5474,9 @@
                 <a:solidFill>
                   <a:srgbClr val="CCCCCC"/>
                 </a:solidFill>
-                <a:latin typeface="마루부리"/>
-                <a:ea typeface="마루부리"/>
-                <a:cs typeface="마루부리"/>
+                <a:latin typeface="Pretendard"/>
+                <a:ea typeface="Pretendard"/>
+                <a:cs typeface="Pretendard"/>
               </a:rPr>
               <a:t>03 / 09</a:t>
             </a:r>
@@ -5573,9 +5573,9 @@
                 <a:solidFill>
                   <a:srgbClr val="0066CC"/>
                 </a:solidFill>
-                <a:latin typeface="마루부리"/>
-                <a:ea typeface="마루부리"/>
-                <a:cs typeface="마루부리"/>
+                <a:latin typeface="Pretendard"/>
+                <a:ea typeface="Pretendard"/>
+                <a:cs typeface="Pretendard"/>
               </a:rPr>
               <a:t>02  SYMBOLISM</a:t>
             </a:r>
@@ -5610,9 +5610,9 @@
                 <a:solidFill>
                   <a:srgbClr val="1D1D1F"/>
                 </a:solidFill>
-                <a:latin typeface="마루부리"/>
-                <a:ea typeface="마루부리"/>
-                <a:cs typeface="마루부리"/>
+                <a:latin typeface="Pretendard"/>
+                <a:ea typeface="Pretendard"/>
+                <a:cs typeface="Pretendard"/>
               </a:rPr>
               <a:t>상징성</a:t>
             </a:r>
@@ -5651,9 +5651,9 @@
                 <a:solidFill>
                   <a:srgbClr val="7A7A7A"/>
                 </a:solidFill>
-                <a:latin typeface="마루부리"/>
-                <a:ea typeface="마루부리"/>
-                <a:cs typeface="마루부리"/>
+                <a:latin typeface="Pretendard"/>
+                <a:ea typeface="Pretendard"/>
+                <a:cs typeface="Pretendard"/>
               </a:rPr>
               <a:t>상품 · 컬러 · 컨셉 · 브랜드 메시지로 구축한 브랜드 아이덴티티</a:t>
             </a:r>
@@ -5736,9 +5736,9 @@
                 <a:solidFill>
                   <a:srgbClr val="1D1D1F"/>
                 </a:solidFill>
-                <a:latin typeface="마루부리"/>
-                <a:ea typeface="마루부리"/>
-                <a:cs typeface="마루부리"/>
+                <a:latin typeface="Pretendard"/>
+                <a:ea typeface="Pretendard"/>
+                <a:cs typeface="Pretendard"/>
               </a:rPr>
               <a:t>[1] 상품  Products</a:t>
             </a:r>
@@ -5777,9 +5777,9 @@
                 <a:solidFill>
                   <a:srgbClr val="333333"/>
                 </a:solidFill>
-                <a:latin typeface="마루부리"/>
-                <a:ea typeface="마루부리"/>
-                <a:cs typeface="마루부리"/>
+                <a:latin typeface="Pretendard"/>
+                <a:ea typeface="Pretendard"/>
+                <a:cs typeface="Pretendard"/>
               </a:rPr>
               <a:t>시그니처 스칼프 샴푸(톳수·창포뿌리줄기수 베이스, 식약처 허가 최대치 식물성 카페인)와 두피 앰플(마이크로 스피큘 니들샷 공법)을 중앙 매대에 배치, 고기능성 기술력을 직관적으로 체험.</a:t>
             </a:r>
@@ -5862,9 +5862,9 @@
                 <a:solidFill>
                   <a:srgbClr val="1D1D1F"/>
                 </a:solidFill>
-                <a:latin typeface="마루부리"/>
-                <a:ea typeface="마루부리"/>
-                <a:cs typeface="마루부리"/>
+                <a:latin typeface="Pretendard"/>
+                <a:ea typeface="Pretendard"/>
+                <a:cs typeface="Pretendard"/>
               </a:rPr>
               <a:t>[2] 컬러  Color</a:t>
             </a:r>
@@ -5903,9 +5903,9 @@
                 <a:solidFill>
                   <a:srgbClr val="333333"/>
                 </a:solidFill>
-                <a:latin typeface="마루부리"/>
-                <a:ea typeface="마루부리"/>
-                <a:cs typeface="마루부리"/>
+                <a:latin typeface="Pretendard"/>
+                <a:ea typeface="Pretendard"/>
+                <a:cs typeface="Pretendard"/>
               </a:rPr>
               <a:t>메인 스카이 블루(청량함·두피 회복)로 시선을 사로잡고, 미니멀 화이트&amp;그레이(정직함·과학적 근거)로 패키지·베이스 톤을 구성해 신뢰감 있는 무드 조성.</a:t>
             </a:r>
@@ -5988,9 +5988,9 @@
                 <a:solidFill>
                   <a:srgbClr val="1D1D1F"/>
                 </a:solidFill>
-                <a:latin typeface="마루부리"/>
-                <a:ea typeface="마루부리"/>
-                <a:cs typeface="마루부리"/>
+                <a:latin typeface="Pretendard"/>
+                <a:ea typeface="Pretendard"/>
+                <a:cs typeface="Pretendard"/>
               </a:rPr>
               <a:t>[3] 컨셉  Concept</a:t>
             </a:r>
@@ -6029,9 +6029,9 @@
                 <a:solidFill>
                   <a:srgbClr val="333333"/>
                 </a:solidFill>
-                <a:latin typeface="마루부리"/>
-                <a:ea typeface="마루부리"/>
-                <a:cs typeface="마루부리"/>
+                <a:latin typeface="Pretendard"/>
+                <a:ea typeface="Pretendard"/>
+                <a:cs typeface="Pretendard"/>
               </a:rPr>
               <a:t>원료 설명 카드·감성 엽서로 ‘정직한 성분 연구소’를 전달. 스크런치 안내와 티코스터 증정을 통해 ‘산뜻한 데일리 루틴’을 경험으로 소유하게 설계.</a:t>
             </a:r>
@@ -6160,9 +6160,9 @@
                 <a:solidFill>
                   <a:srgbClr val="1D1D1F"/>
                 </a:solidFill>
-                <a:latin typeface="마루부리"/>
-                <a:ea typeface="마루부리"/>
-                <a:cs typeface="마루부리"/>
+                <a:latin typeface="Pretendard"/>
+                <a:ea typeface="Pretendard"/>
+                <a:cs typeface="Pretendard"/>
               </a:rPr>
               <a:t>[4] 브랜드 메시지  Message</a:t>
             </a:r>
@@ -6201,9 +6201,9 @@
                 <a:solidFill>
                   <a:srgbClr val="333333"/>
                 </a:solidFill>
-                <a:latin typeface="마루부리"/>
-                <a:ea typeface="마루부리"/>
-                <a:cs typeface="마루부리"/>
+                <a:latin typeface="Pretendard"/>
+                <a:ea typeface="Pretendard"/>
+                <a:cs typeface="Pretendard"/>
               </a:rPr>
               <a:t>“Pure Origin, Real Change” — 순수한 핵심 원료(Pure Origin)를 고함량 설계해 실제 두피 개선과 긍정적 효과(Real Change)를 체감하게 한다는 약속.</a:t>
             </a:r>
@@ -6238,9 +6238,9 @@
                 <a:solidFill>
                   <a:srgbClr val="7A7A7A"/>
                 </a:solidFill>
-                <a:latin typeface="마루부리"/>
-                <a:ea typeface="마루부리"/>
-                <a:cs typeface="마루부리"/>
+                <a:latin typeface="Pretendard"/>
+                <a:ea typeface="Pretendard"/>
+                <a:cs typeface="Pretendard"/>
               </a:rPr>
               <a:t>moét × ONVIEW · BEAUTY PLAYGROUND IN SEONGSU</a:t>
             </a:r>
@@ -6275,9 +6275,9 @@
                 <a:solidFill>
                   <a:srgbClr val="7A7A7A"/>
                 </a:solidFill>
-                <a:latin typeface="마루부리"/>
-                <a:ea typeface="마루부리"/>
-                <a:cs typeface="마루부리"/>
+                <a:latin typeface="Pretendard"/>
+                <a:ea typeface="Pretendard"/>
+                <a:cs typeface="Pretendard"/>
               </a:rPr>
               <a:t>04 / 09</a:t>
             </a:r>
@@ -6374,9 +6374,9 @@
                 <a:solidFill>
                   <a:srgbClr val="2997FF"/>
                 </a:solidFill>
-                <a:latin typeface="마루부리"/>
-                <a:ea typeface="마루부리"/>
-                <a:cs typeface="마루부리"/>
+                <a:latin typeface="Pretendard"/>
+                <a:ea typeface="Pretendard"/>
+                <a:cs typeface="Pretendard"/>
               </a:rPr>
               <a:t>03  THEMATIC</a:t>
             </a:r>
@@ -6411,9 +6411,9 @@
                 <a:solidFill>
                   <a:srgbClr val="FFFFFF"/>
                 </a:solidFill>
-                <a:latin typeface="마루부리"/>
-                <a:ea typeface="마루부리"/>
-                <a:cs typeface="마루부리"/>
+                <a:latin typeface="Pretendard"/>
+                <a:ea typeface="Pretendard"/>
+                <a:cs typeface="Pretendard"/>
               </a:rPr>
               <a:t>테마성</a:t>
             </a:r>
@@ -6452,9 +6452,9 @@
                 <a:solidFill>
                   <a:srgbClr val="CCCCCC"/>
                 </a:solidFill>
-                <a:latin typeface="마루부리"/>
-                <a:ea typeface="마루부리"/>
-                <a:cs typeface="마루부리"/>
+                <a:latin typeface="Pretendard"/>
+                <a:ea typeface="Pretendard"/>
+                <a:cs typeface="Pretendard"/>
               </a:rPr>
               <a:t>‘Pure Origin, Real Change’ — 체험 중심의 고기능성 헤어 랩(Lab)</a:t>
             </a:r>
@@ -6581,9 +6581,9 @@
                 <a:solidFill>
                   <a:srgbClr val="FFFFFF"/>
                 </a:solidFill>
-                <a:latin typeface="마루부리"/>
-                <a:ea typeface="마루부리"/>
-                <a:cs typeface="마루부리"/>
+                <a:latin typeface="Pretendard"/>
+                <a:ea typeface="Pretendard"/>
+                <a:cs typeface="Pretendard"/>
               </a:rPr>
               <a:t>메인 테마의 구체화</a:t>
             </a:r>
@@ -6622,9 +6622,9 @@
                 <a:solidFill>
                   <a:srgbClr val="CCCCCC"/>
                 </a:solidFill>
-                <a:latin typeface="마루부리"/>
-                <a:ea typeface="마루부리"/>
-                <a:cs typeface="마루부리"/>
+                <a:latin typeface="Pretendard"/>
+                <a:ea typeface="Pretendard"/>
+                <a:cs typeface="Pretendard"/>
               </a:rPr>
               <a:t>‘뷰티 놀이터(Playground)’라는 전체 테마 속에서 ‘자극 없는 일상 속 두피 회복 솔루션’을 서브 테마로 명확히 제안.</a:t>
             </a:r>
@@ -6705,9 +6705,9 @@
                 <a:solidFill>
                   <a:srgbClr val="FFFFFF"/>
                 </a:solidFill>
-                <a:latin typeface="마루부리"/>
-                <a:ea typeface="마루부리"/>
-                <a:cs typeface="마루부리"/>
+                <a:latin typeface="Pretendard"/>
+                <a:ea typeface="Pretendard"/>
+                <a:cs typeface="Pretendard"/>
               </a:rPr>
               <a:t>콘셉추얼한 매대 구성</a:t>
             </a:r>
@@ -6746,9 +6746,9 @@
                 <a:solidFill>
                   <a:srgbClr val="CCCCCC"/>
                 </a:solidFill>
-                <a:latin typeface="마루부리"/>
-                <a:ea typeface="마루부리"/>
-                <a:cs typeface="마루부리"/>
+                <a:latin typeface="Pretendard"/>
+                <a:ea typeface="Pretendard"/>
+                <a:cs typeface="Pretendard"/>
               </a:rPr>
               <a:t>단순 진열·판매를 넘어, 방문객이 자신의 두피 고민(열감·모발 빠짐·유분)을 인지하고 해답을 스스로 탐색하는 서사적 공간으로 연출.</a:t>
             </a:r>
@@ -6886,9 +6886,9 @@
                 <a:solidFill>
                   <a:srgbClr val="CCCCCC"/>
                 </a:solidFill>
-                <a:latin typeface="마루부리"/>
-                <a:ea typeface="마루부리"/>
-                <a:cs typeface="마루부리"/>
+                <a:latin typeface="Pretendard"/>
+                <a:ea typeface="Pretendard"/>
+                <a:cs typeface="Pretendard"/>
               </a:rPr>
               <a:t>제품/현장 이미지</a:t>
             </a:r>
@@ -6904,9 +6904,9 @@
                 <a:solidFill>
                   <a:srgbClr val="CCCCCC"/>
                 </a:solidFill>
-                <a:latin typeface="마루부리"/>
-                <a:ea typeface="마루부리"/>
-                <a:cs typeface="마루부리"/>
+                <a:latin typeface="Pretendard"/>
+                <a:ea typeface="Pretendard"/>
+                <a:cs typeface="Pretendard"/>
               </a:rPr>
               <a:t/>
             </a:r>
@@ -6922,9 +6922,9 @@
                 <a:solidFill>
                   <a:srgbClr val="CCCCCC"/>
                 </a:solidFill>
-                <a:latin typeface="마루부리"/>
-                <a:ea typeface="마루부리"/>
-                <a:cs typeface="마루부리"/>
+                <a:latin typeface="Pretendard"/>
+                <a:ea typeface="Pretendard"/>
+                <a:cs typeface="Pretendard"/>
               </a:rPr>
               <a:t>원료 설명 리플렛·감성 엽서가 함께 디스플레이된 매대</a:t>
             </a:r>
@@ -6959,9 +6959,9 @@
                 <a:solidFill>
                   <a:srgbClr val="CCCCCC"/>
                 </a:solidFill>
-                <a:latin typeface="마루부리"/>
-                <a:ea typeface="마루부리"/>
-                <a:cs typeface="마루부리"/>
+                <a:latin typeface="Pretendard"/>
+                <a:ea typeface="Pretendard"/>
+                <a:cs typeface="Pretendard"/>
               </a:rPr>
               <a:t>moét × ONVIEW · BEAUTY PLAYGROUND IN SEONGSU</a:t>
             </a:r>
@@ -6996,9 +6996,9 @@
                 <a:solidFill>
                   <a:srgbClr val="CCCCCC"/>
                 </a:solidFill>
-                <a:latin typeface="마루부리"/>
-                <a:ea typeface="마루부리"/>
-                <a:cs typeface="마루부리"/>
+                <a:latin typeface="Pretendard"/>
+                <a:ea typeface="Pretendard"/>
+                <a:cs typeface="Pretendard"/>
               </a:rPr>
               <a:t>05 / 09</a:t>
             </a:r>
@@ -7095,9 +7095,9 @@
                 <a:solidFill>
                   <a:srgbClr val="0066CC"/>
                 </a:solidFill>
-                <a:latin typeface="마루부리"/>
-                <a:ea typeface="마루부리"/>
-                <a:cs typeface="마루부리"/>
+                <a:latin typeface="Pretendard"/>
+                <a:ea typeface="Pretendard"/>
+                <a:cs typeface="Pretendard"/>
               </a:rPr>
               <a:t>04  CONTENTS</a:t>
             </a:r>
@@ -7132,9 +7132,9 @@
                 <a:solidFill>
                   <a:srgbClr val="1D1D1F"/>
                 </a:solidFill>
-                <a:latin typeface="마루부리"/>
-                <a:ea typeface="마루부리"/>
-                <a:cs typeface="마루부리"/>
+                <a:latin typeface="Pretendard"/>
+                <a:ea typeface="Pretendard"/>
+                <a:cs typeface="Pretendard"/>
               </a:rPr>
               <a:t>콘텐츠</a:t>
             </a:r>
@@ -7173,9 +7173,9 @@
                 <a:solidFill>
                   <a:srgbClr val="7A7A7A"/>
                 </a:solidFill>
-                <a:latin typeface="마루부리"/>
-                <a:ea typeface="마루부리"/>
-                <a:cs typeface="마루부리"/>
+                <a:latin typeface="Pretendard"/>
+                <a:ea typeface="Pretendard"/>
+                <a:cs typeface="Pretendard"/>
               </a:rPr>
               <a:t>방문객의 오감을 자극하는 참여형 저니(Journey) 설계</a:t>
             </a:r>
@@ -7258,9 +7258,9 @@
                 <a:solidFill>
                   <a:srgbClr val="1D1D1F"/>
                 </a:solidFill>
-                <a:latin typeface="마루부리"/>
-                <a:ea typeface="마루부리"/>
-                <a:cs typeface="마루부리"/>
+                <a:latin typeface="Pretendard"/>
+                <a:ea typeface="Pretendard"/>
+                <a:cs typeface="Pretendard"/>
               </a:rPr>
               <a:t>원료 스토리텔링 · 시향</a:t>
             </a:r>
@@ -7299,9 +7299,9 @@
                 <a:solidFill>
                   <a:srgbClr val="333333"/>
                 </a:solidFill>
-                <a:latin typeface="마루부리"/>
-                <a:ea typeface="마루부리"/>
-                <a:cs typeface="마루부리"/>
+                <a:latin typeface="Pretendard"/>
+                <a:ea typeface="Pretendard"/>
+                <a:cs typeface="Pretendard"/>
               </a:rPr>
               <a:t>특허 ‘톳인삼농축액’, 고함량 식물성 카페인을 코칭하고, 세련된 플로럴 머스크 향을 직접 맡게 하는 청각·후각 콘텐츠.</a:t>
             </a:r>
@@ -7430,9 +7430,9 @@
                 <a:solidFill>
                   <a:srgbClr val="1D1D1F"/>
                 </a:solidFill>
-                <a:latin typeface="마루부리"/>
-                <a:ea typeface="마루부리"/>
-                <a:cs typeface="마루부리"/>
+                <a:latin typeface="Pretendard"/>
+                <a:ea typeface="Pretendard"/>
+                <a:cs typeface="Pretendard"/>
               </a:rPr>
               <a:t>촉각적 제형 테스트</a:t>
             </a:r>
@@ -7471,9 +7471,9 @@
                 <a:solidFill>
                   <a:srgbClr val="333333"/>
                 </a:solidFill>
-                <a:latin typeface="마루부리"/>
-                <a:ea typeface="마루부리"/>
-                <a:cs typeface="마루부리"/>
+                <a:latin typeface="Pretendard"/>
+                <a:ea typeface="Pretendard"/>
+                <a:cs typeface="Pretendard"/>
               </a:rPr>
               <a:t>마이크로 스피큘(니들샷) 두피 앰플을 손등에 발라보게 해 ‘끈적임 없는 흡수력’과 ‘즉각적 쿨링감’을 현장 체감.</a:t>
             </a:r>
@@ -7556,9 +7556,9 @@
                 <a:solidFill>
                   <a:srgbClr val="1D1D1F"/>
                 </a:solidFill>
-                <a:latin typeface="마루부리"/>
-                <a:ea typeface="마루부리"/>
-                <a:cs typeface="마루부리"/>
+                <a:latin typeface="Pretendard"/>
+                <a:ea typeface="Pretendard"/>
+                <a:cs typeface="Pretendard"/>
               </a:rPr>
               <a:t>엔터테인먼트 요소</a:t>
             </a:r>
@@ -7597,9 +7597,9 @@
                 <a:solidFill>
                   <a:srgbClr val="333333"/>
                 </a:solidFill>
-                <a:latin typeface="마루부리"/>
-                <a:ea typeface="마루부리"/>
-                <a:cs typeface="마루부리"/>
+                <a:latin typeface="Pretendard"/>
+                <a:ea typeface="Pretendard"/>
+                <a:cs typeface="Pretendard"/>
               </a:rPr>
               <a:t>카카오톡 채널 추가·인스타그램 팔로우 시 ‘꽝 없는 100% 당첨 럭키드로우’ 뽑기 게임으로 참여 재미 극대화.</a:t>
             </a:r>
@@ -7737,9 +7737,9 @@
                 <a:solidFill>
                   <a:srgbClr val="7A7A7A"/>
                 </a:solidFill>
-                <a:latin typeface="마루부리"/>
-                <a:ea typeface="마루부리"/>
-                <a:cs typeface="마루부리"/>
+                <a:latin typeface="Pretendard"/>
+                <a:ea typeface="Pretendard"/>
+                <a:cs typeface="Pretendard"/>
               </a:rPr>
               <a:t>제품/현장 이미지</a:t>
             </a:r>
@@ -7755,9 +7755,9 @@
                 <a:solidFill>
                   <a:srgbClr val="7A7A7A"/>
                 </a:solidFill>
-                <a:latin typeface="마루부리"/>
-                <a:ea typeface="마루부리"/>
-                <a:cs typeface="마루부리"/>
+                <a:latin typeface="Pretendard"/>
+                <a:ea typeface="Pretendard"/>
+                <a:cs typeface="Pretendard"/>
               </a:rPr>
               <a:t/>
             </a:r>
@@ -7773,9 +7773,9 @@
                 <a:solidFill>
                   <a:srgbClr val="7A7A7A"/>
                 </a:solidFill>
-                <a:latin typeface="마루부리"/>
-                <a:ea typeface="마루부리"/>
-                <a:cs typeface="마루부리"/>
+                <a:latin typeface="Pretendard"/>
+                <a:ea typeface="Pretendard"/>
+                <a:cs typeface="Pretendard"/>
               </a:rPr>
               <a:t>두피 앰플 테스팅 장면 및 럭키드로우 돌리기 기계</a:t>
             </a:r>
@@ -7810,9 +7810,9 @@
                 <a:solidFill>
                   <a:srgbClr val="7A7A7A"/>
                 </a:solidFill>
-                <a:latin typeface="마루부리"/>
-                <a:ea typeface="마루부리"/>
-                <a:cs typeface="마루부리"/>
+                <a:latin typeface="Pretendard"/>
+                <a:ea typeface="Pretendard"/>
+                <a:cs typeface="Pretendard"/>
               </a:rPr>
               <a:t>moét × ONVIEW · BEAUTY PLAYGROUND IN SEONGSU</a:t>
             </a:r>
@@ -7847,9 +7847,9 @@
                 <a:solidFill>
                   <a:srgbClr val="7A7A7A"/>
                 </a:solidFill>
-                <a:latin typeface="마루부리"/>
-                <a:ea typeface="마루부리"/>
-                <a:cs typeface="마루부리"/>
+                <a:latin typeface="Pretendard"/>
+                <a:ea typeface="Pretendard"/>
+                <a:cs typeface="Pretendard"/>
               </a:rPr>
               <a:t>06 / 09</a:t>
             </a:r>
@@ -7946,9 +7946,9 @@
                 <a:solidFill>
                   <a:srgbClr val="2997FF"/>
                 </a:solidFill>
-                <a:latin typeface="마루부리"/>
-                <a:ea typeface="마루부리"/>
-                <a:cs typeface="마루부리"/>
+                <a:latin typeface="Pretendard"/>
+                <a:ea typeface="Pretendard"/>
+                <a:cs typeface="Pretendard"/>
               </a:rPr>
               <a:t>05  BUZZ</a:t>
             </a:r>
@@ -7983,9 +7983,9 @@
                 <a:solidFill>
                   <a:srgbClr val="FFFFFF"/>
                 </a:solidFill>
-                <a:latin typeface="마루부리"/>
-                <a:ea typeface="마루부리"/>
-                <a:cs typeface="마루부리"/>
+                <a:latin typeface="Pretendard"/>
+                <a:ea typeface="Pretendard"/>
+                <a:cs typeface="Pretendard"/>
               </a:rPr>
               <a:t>화제성</a:t>
             </a:r>
@@ -8024,9 +8024,9 @@
                 <a:solidFill>
                   <a:srgbClr val="CCCCCC"/>
                 </a:solidFill>
-                <a:latin typeface="마루부리"/>
-                <a:ea typeface="마루부리"/>
-                <a:cs typeface="마루부리"/>
+                <a:latin typeface="Pretendard"/>
+                <a:ea typeface="Pretendard"/>
+                <a:cs typeface="Pretendard"/>
               </a:rPr>
               <a:t>‘혜자 팝업’ 입소문과 SNS 자발적 바이럴 효과</a:t>
             </a:r>
@@ -8153,9 +8153,9 @@
                 <a:solidFill>
                   <a:srgbClr val="FFFFFF"/>
                 </a:solidFill>
-                <a:latin typeface="마루부리"/>
-                <a:ea typeface="마루부리"/>
-                <a:cs typeface="마루부리"/>
+                <a:latin typeface="Pretendard"/>
+                <a:ea typeface="Pretendard"/>
+                <a:cs typeface="Pretendard"/>
               </a:rPr>
               <a:t>얼리버드 유입 (오픈런)</a:t>
             </a:r>
@@ -8194,9 +8194,9 @@
                 <a:solidFill>
                   <a:srgbClr val="CCCCCC"/>
                 </a:solidFill>
-                <a:latin typeface="마루부리"/>
-                <a:ea typeface="마루부리"/>
-                <a:cs typeface="마루부리"/>
+                <a:latin typeface="Pretendard"/>
+                <a:ea typeface="Pretendard"/>
+                <a:cs typeface="Pretendard"/>
               </a:rPr>
               <a:t>“다양한 인디 뷰티 본품 혜택과 다채로운 이벤트”라는 정보가 온라인 뷰티 커뮤니티·SNS로 확산되며 오전 11시 오픈 전부터 대기 수요 발생.</a:t>
             </a:r>
@@ -8277,9 +8277,9 @@
                 <a:solidFill>
                   <a:srgbClr val="FFFFFF"/>
                 </a:solidFill>
-                <a:latin typeface="마루부리"/>
-                <a:ea typeface="마루부리"/>
-                <a:cs typeface="마루부리"/>
+                <a:latin typeface="Pretendard"/>
+                <a:ea typeface="Pretendard"/>
+                <a:cs typeface="Pretendard"/>
               </a:rPr>
               <a:t>공유 가치가 있는 굿즈</a:t>
             </a:r>
@@ -8318,9 +8318,9 @@
                 <a:solidFill>
                   <a:srgbClr val="CCCCCC"/>
                 </a:solidFill>
-                <a:latin typeface="마루부리"/>
-                <a:ea typeface="마루부리"/>
-                <a:cs typeface="마루부리"/>
+                <a:latin typeface="Pretendard"/>
+                <a:ea typeface="Pretendard"/>
+                <a:cs typeface="Pretendard"/>
               </a:rPr>
               <a:t>소장 가치 높은 티코스터와 세련된 스크런치 증정으로, 방문객이 자발적으로 #모에뜨 #성수팝업 인증샷을 업로드하도록 유도.</a:t>
             </a:r>
@@ -8458,9 +8458,9 @@
                 <a:solidFill>
                   <a:srgbClr val="CCCCCC"/>
                 </a:solidFill>
-                <a:latin typeface="마루부리"/>
-                <a:ea typeface="마루부리"/>
-                <a:cs typeface="마루부리"/>
+                <a:latin typeface="Pretendard"/>
+                <a:ea typeface="Pretendard"/>
+                <a:cs typeface="Pretendard"/>
               </a:rPr>
               <a:t>제품/현장 이미지</a:t>
             </a:r>
@@ -8476,9 +8476,9 @@
                 <a:solidFill>
                   <a:srgbClr val="CCCCCC"/>
                 </a:solidFill>
-                <a:latin typeface="마루부리"/>
-                <a:ea typeface="마루부리"/>
-                <a:cs typeface="마루부리"/>
+                <a:latin typeface="Pretendard"/>
+                <a:ea typeface="Pretendard"/>
+                <a:cs typeface="Pretendard"/>
               </a:rPr>
               <a:t/>
             </a:r>
@@ -8494,9 +8494,9 @@
                 <a:solidFill>
                   <a:srgbClr val="CCCCCC"/>
                 </a:solidFill>
-                <a:latin typeface="마루부리"/>
-                <a:ea typeface="마루부리"/>
-                <a:cs typeface="마루부리"/>
+                <a:latin typeface="Pretendard"/>
+                <a:ea typeface="Pretendard"/>
+                <a:cs typeface="Pretendard"/>
               </a:rPr>
               <a:t>인스타그램 피드 캡처 · 방문 인플루언서 인증샷 레이아웃</a:t>
             </a:r>
@@ -8531,9 +8531,9 @@
                 <a:solidFill>
                   <a:srgbClr val="CCCCCC"/>
                 </a:solidFill>
-                <a:latin typeface="마루부리"/>
-                <a:ea typeface="마루부리"/>
-                <a:cs typeface="마루부리"/>
+                <a:latin typeface="Pretendard"/>
+                <a:ea typeface="Pretendard"/>
+                <a:cs typeface="Pretendard"/>
               </a:rPr>
               <a:t>moét × ONVIEW · BEAUTY PLAYGROUND IN SEONGSU</a:t>
             </a:r>
@@ -8568,9 +8568,9 @@
                 <a:solidFill>
                   <a:srgbClr val="CCCCCC"/>
                 </a:solidFill>
-                <a:latin typeface="마루부리"/>
-                <a:ea typeface="마루부리"/>
-                <a:cs typeface="마루부리"/>
+                <a:latin typeface="Pretendard"/>
+                <a:ea typeface="Pretendard"/>
+                <a:cs typeface="Pretendard"/>
               </a:rPr>
               <a:t>07 / 09</a:t>
             </a:r>
@@ -8667,9 +8667,9 @@
                 <a:solidFill>
                   <a:srgbClr val="0066CC"/>
                 </a:solidFill>
-                <a:latin typeface="마루부리"/>
-                <a:ea typeface="마루부리"/>
-                <a:cs typeface="마루부리"/>
+                <a:latin typeface="Pretendard"/>
+                <a:ea typeface="Pretendard"/>
+                <a:cs typeface="Pretendard"/>
               </a:rPr>
               <a:t>06  INDUCEMENT</a:t>
             </a:r>
@@ -8704,9 +8704,9 @@
                 <a:solidFill>
                   <a:srgbClr val="1D1D1F"/>
                 </a:solidFill>
-                <a:latin typeface="마루부리"/>
-                <a:ea typeface="마루부리"/>
-                <a:cs typeface="마루부리"/>
+                <a:latin typeface="Pretendard"/>
+                <a:ea typeface="Pretendard"/>
+                <a:cs typeface="Pretendard"/>
               </a:rPr>
               <a:t>유도성</a:t>
             </a:r>
@@ -8745,9 +8745,9 @@
                 <a:solidFill>
                   <a:srgbClr val="7A7A7A"/>
                 </a:solidFill>
-                <a:latin typeface="마루부리"/>
-                <a:ea typeface="마루부리"/>
-                <a:cs typeface="마루부리"/>
+                <a:latin typeface="Pretendard"/>
+                <a:ea typeface="Pretendard"/>
+                <a:cs typeface="Pretendard"/>
               </a:rPr>
               <a:t>오프라인 구매 전환과 온라인 록인(Lock-in)의 연계</a:t>
             </a:r>
@@ -8830,9 +8830,9 @@
                 <a:solidFill>
                   <a:srgbClr val="1D1D1F"/>
                 </a:solidFill>
-                <a:latin typeface="마루부리"/>
-                <a:ea typeface="마루부리"/>
-                <a:cs typeface="마루부리"/>
+                <a:latin typeface="Pretendard"/>
+                <a:ea typeface="Pretendard"/>
+                <a:cs typeface="Pretendard"/>
               </a:rPr>
               <a:t>즉각적 구매 동기부여</a:t>
             </a:r>
@@ -8871,9 +8871,9 @@
                 <a:solidFill>
                   <a:srgbClr val="333333"/>
                 </a:solidFill>
-                <a:latin typeface="마루부리"/>
-                <a:ea typeface="마루부리"/>
-                <a:cs typeface="마루부리"/>
+                <a:latin typeface="Pretendard"/>
+                <a:ea typeface="Pretendard"/>
+                <a:cs typeface="Pretendard"/>
               </a:rPr>
               <a:t>전 제품 50%~최대 58% 파격 팝업 한정 할인가로 가격 장벽을 무너뜨려 현장 구매를 강력히 유도.</a:t>
             </a:r>
@@ -8956,9 +8956,9 @@
                 <a:solidFill>
                   <a:srgbClr val="1D1D1F"/>
                 </a:solidFill>
-                <a:latin typeface="마루부리"/>
-                <a:ea typeface="마루부리"/>
-                <a:cs typeface="마루부리"/>
+                <a:latin typeface="Pretendard"/>
+                <a:ea typeface="Pretendard"/>
+                <a:cs typeface="Pretendard"/>
               </a:rPr>
               <a:t>구매 넛지(Nudge) 설계</a:t>
             </a:r>
@@ -8997,9 +8997,9 @@
                 <a:solidFill>
                   <a:srgbClr val="333333"/>
                 </a:solidFill>
-                <a:latin typeface="마루부리"/>
-                <a:ea typeface="마루부리"/>
-                <a:cs typeface="마루부리"/>
+                <a:latin typeface="Pretendard"/>
+                <a:ea typeface="Pretendard"/>
+                <a:cs typeface="Pretendard"/>
               </a:rPr>
               <a:t>‘1개 구매 시 티코스터, 2개 이상 구매 시 스크런치 추가’ 단계별 사은품으로 자연스러운 객단가 상승 유도.</a:t>
             </a:r>
@@ -9128,9 +9128,9 @@
                 <a:solidFill>
                   <a:srgbClr val="1D1D1F"/>
                 </a:solidFill>
-                <a:latin typeface="마루부리"/>
-                <a:ea typeface="마루부리"/>
-                <a:cs typeface="마루부리"/>
+                <a:latin typeface="Pretendard"/>
+                <a:ea typeface="Pretendard"/>
+                <a:cs typeface="Pretendard"/>
               </a:rPr>
               <a:t>온라인 재유입 전략</a:t>
             </a:r>
@@ -9169,9 +9169,9 @@
                 <a:solidFill>
                   <a:srgbClr val="333333"/>
                 </a:solidFill>
-                <a:latin typeface="마루부리"/>
-                <a:ea typeface="마루부리"/>
-                <a:cs typeface="마루부리"/>
+                <a:latin typeface="Pretendard"/>
+                <a:ea typeface="Pretendard"/>
+                <a:cs typeface="Pretendard"/>
               </a:rPr>
               <a:t>럭키드로우 상품으로 ‘자사몰 1만원 할인 쿠폰’을 설계, 팝업 종료 후에도 온라인 채널로 지속 유입되는 록인 장치 마련.</a:t>
             </a:r>
@@ -9252,9 +9252,9 @@
                 <a:solidFill>
                   <a:srgbClr val="7A7A7A"/>
                 </a:solidFill>
-                <a:latin typeface="마루부리"/>
-                <a:ea typeface="마루부리"/>
-                <a:cs typeface="마루부리"/>
+                <a:latin typeface="Pretendard"/>
+                <a:ea typeface="Pretendard"/>
+                <a:cs typeface="Pretendard"/>
               </a:rPr>
               <a:t>팝업 한정 할인율</a:t>
             </a:r>
@@ -9289,9 +9289,9 @@
                 <a:solidFill>
                   <a:srgbClr val="1D1D1F"/>
                 </a:solidFill>
-                <a:latin typeface="마루부리"/>
-                <a:ea typeface="마루부리"/>
-                <a:cs typeface="마루부리"/>
+                <a:latin typeface="Pretendard"/>
+                <a:ea typeface="Pretendard"/>
+                <a:cs typeface="Pretendard"/>
               </a:rPr>
               <a:t>50–58</a:t>
             </a:r>
@@ -9303,9 +9303,9 @@
                 <a:solidFill>
                   <a:srgbClr val="0066CC"/>
                 </a:solidFill>
-                <a:latin typeface="마루부리"/>
-                <a:ea typeface="마루부리"/>
-                <a:cs typeface="마루부리"/>
+                <a:latin typeface="Pretendard"/>
+                <a:ea typeface="Pretendard"/>
+                <a:cs typeface="Pretendard"/>
               </a:rPr>
               <a:t>%</a:t>
             </a:r>
@@ -9340,9 +9340,9 @@
                 <a:solidFill>
                   <a:srgbClr val="7A7A7A"/>
                 </a:solidFill>
-                <a:latin typeface="마루부리"/>
-                <a:ea typeface="마루부리"/>
-                <a:cs typeface="마루부리"/>
+                <a:latin typeface="Pretendard"/>
+                <a:ea typeface="Pretendard"/>
+                <a:cs typeface="Pretendard"/>
               </a:rPr>
               <a:t>전 제품 기준 최대 할인 · 현장 구매 전환 극대화</a:t>
             </a:r>
@@ -9480,9 +9480,9 @@
                 <a:solidFill>
                   <a:srgbClr val="7A7A7A"/>
                 </a:solidFill>
-                <a:latin typeface="마루부리"/>
-                <a:ea typeface="마루부리"/>
-                <a:cs typeface="마루부리"/>
+                <a:latin typeface="Pretendard"/>
+                <a:ea typeface="Pretendard"/>
+                <a:cs typeface="Pretendard"/>
               </a:rPr>
               <a:t>제품/현장 이미지</a:t>
             </a:r>
@@ -9498,9 +9498,9 @@
                 <a:solidFill>
                   <a:srgbClr val="7A7A7A"/>
                 </a:solidFill>
-                <a:latin typeface="마루부리"/>
-                <a:ea typeface="마루부리"/>
-                <a:cs typeface="마루부리"/>
+                <a:latin typeface="Pretendard"/>
+                <a:ea typeface="Pretendard"/>
+                <a:cs typeface="Pretendard"/>
               </a:rPr>
               <a:t/>
             </a:r>
@@ -9516,9 +9516,9 @@
                 <a:solidFill>
                   <a:srgbClr val="7A7A7A"/>
                 </a:solidFill>
-                <a:latin typeface="마루부리"/>
-                <a:ea typeface="마루부리"/>
-                <a:cs typeface="마루부리"/>
+                <a:latin typeface="Pretendard"/>
+                <a:ea typeface="Pretendard"/>
+                <a:cs typeface="Pretendard"/>
               </a:rPr>
               <a:t>샴푸·티코스터·스크런치 언박싱 컷</a:t>
             </a:r>
@@ -9553,9 +9553,9 @@
                 <a:solidFill>
                   <a:srgbClr val="7A7A7A"/>
                 </a:solidFill>
-                <a:latin typeface="마루부리"/>
-                <a:ea typeface="마루부리"/>
-                <a:cs typeface="마루부리"/>
+                <a:latin typeface="Pretendard"/>
+                <a:ea typeface="Pretendard"/>
+                <a:cs typeface="Pretendard"/>
               </a:rPr>
               <a:t>moét × ONVIEW · BEAUTY PLAYGROUND IN SEONGSU</a:t>
             </a:r>
@@ -9590,9 +9590,9 @@
                 <a:solidFill>
                   <a:srgbClr val="7A7A7A"/>
                 </a:solidFill>
-                <a:latin typeface="마루부리"/>
-                <a:ea typeface="마루부리"/>
-                <a:cs typeface="마루부리"/>
+                <a:latin typeface="Pretendard"/>
+                <a:ea typeface="Pretendard"/>
+                <a:cs typeface="Pretendard"/>
               </a:rPr>
               <a:t>08 / 09</a:t>
             </a:r>
@@ -9689,9 +9689,9 @@
                 <a:solidFill>
                   <a:srgbClr val="2997FF"/>
                 </a:solidFill>
-                <a:latin typeface="마루부리"/>
-                <a:ea typeface="마루부리"/>
-                <a:cs typeface="마루부리"/>
+                <a:latin typeface="Pretendard"/>
+                <a:ea typeface="Pretendard"/>
+                <a:cs typeface="Pretendard"/>
               </a:rPr>
               <a:t>CONCLUSION</a:t>
             </a:r>
@@ -9726,9 +9726,9 @@
                 <a:solidFill>
                   <a:srgbClr val="FFFFFF"/>
                 </a:solidFill>
-                <a:latin typeface="마루부리"/>
-                <a:ea typeface="마루부리"/>
-                <a:cs typeface="마루부리"/>
+                <a:latin typeface="Pretendard"/>
+                <a:ea typeface="Pretendard"/>
+                <a:cs typeface="Pretendard"/>
               </a:rPr>
               <a:t>결론 및 종합 의견</a:t>
             </a:r>
@@ -9763,9 +9763,9 @@
                 <a:solidFill>
                   <a:srgbClr val="CCCCCC"/>
                 </a:solidFill>
-                <a:latin typeface="마루부리"/>
-                <a:ea typeface="마루부리"/>
-                <a:cs typeface="마루부리"/>
+                <a:latin typeface="Pretendard"/>
+                <a:ea typeface="Pretendard"/>
+                <a:cs typeface="Pretendard"/>
               </a:rPr>
               <a:t>직접 체험하며 느낀 점 및 총평</a:t>
             </a:r>
@@ -9882,9 +9882,9 @@
                 <a:solidFill>
                   <a:srgbClr val="2997FF"/>
                 </a:solidFill>
-                <a:latin typeface="마루부리"/>
-                <a:ea typeface="마루부리"/>
-                <a:cs typeface="마루부리"/>
+                <a:latin typeface="Pretendard"/>
+                <a:ea typeface="Pretendard"/>
+                <a:cs typeface="Pretendard"/>
               </a:rPr>
               <a:t>“</a:t>
             </a:r>
@@ -9923,9 +9923,9 @@
                 <a:solidFill>
                   <a:srgbClr val="FFFFFF"/>
                 </a:solidFill>
-                <a:latin typeface="마루부리"/>
-                <a:ea typeface="마루부리"/>
-                <a:cs typeface="마루부리"/>
+                <a:latin typeface="Pretendard"/>
+                <a:ea typeface="Pretendard"/>
+                <a:cs typeface="Pretendard"/>
               </a:rPr>
               <a:t>외부 자극·스트레스로 두피 고민이 많던 소비자 입장에서 매우 만족스러운 경험. 기능성 탈모 샴푸는 향이 딱딱하고 모발이 뻣뻣해진다는 편견이 있었으나, ‘풍성한 거품·찰랑이는 머릿결·세련된 머스크 향’으로 오프라인 체험이 준 신뢰감을 그대로 이어감.</a:t>
             </a:r>
@@ -10056,9 +10056,9 @@
                 <a:solidFill>
                   <a:srgbClr val="FFFFFF"/>
                 </a:solidFill>
-                <a:latin typeface="마루부리"/>
-                <a:ea typeface="마루부리"/>
-                <a:cs typeface="마루부리"/>
+                <a:latin typeface="Pretendard"/>
+                <a:ea typeface="Pretendard"/>
+                <a:cs typeface="Pretendard"/>
               </a:rPr>
               <a:t>화려한 마케팅 수식어 대신 제품의 본질(Pure Origin)을 강조하고, 이를 성수동이라는 감각적 오프라인 공간 안에서 영리한 혜택 체계(Real Change)로 풀어냄.  </a:t>
             </a:r>
@@ -10074,9 +10074,9 @@
                 <a:solidFill>
                   <a:srgbClr val="2997FF"/>
                 </a:solidFill>
-                <a:latin typeface="마루부리"/>
-                <a:ea typeface="마루부리"/>
-                <a:cs typeface="마루부리"/>
+                <a:latin typeface="Pretendard"/>
+                <a:ea typeface="Pretendard"/>
+                <a:cs typeface="Pretendard"/>
               </a:rPr>
               <a:t>인디 브랜드가 고객 접점을 극대화한 훌륭한 리테일 전략 사례.</a:t>
             </a:r>
@@ -10111,9 +10111,9 @@
                 <a:solidFill>
                   <a:srgbClr val="CCCCCC"/>
                 </a:solidFill>
-                <a:latin typeface="마루부리"/>
-                <a:ea typeface="마루부리"/>
-                <a:cs typeface="마루부리"/>
+                <a:latin typeface="Pretendard"/>
+                <a:ea typeface="Pretendard"/>
+                <a:cs typeface="Pretendard"/>
               </a:rPr>
               <a:t>Pure Origin, Real Change</a:t>
             </a:r>
@@ -10148,9 +10148,9 @@
                 <a:solidFill>
                   <a:srgbClr val="CCCCCC"/>
                 </a:solidFill>
-                <a:latin typeface="마루부리"/>
-                <a:ea typeface="마루부리"/>
-                <a:cs typeface="마루부리"/>
+                <a:latin typeface="Pretendard"/>
+                <a:ea typeface="Pretendard"/>
+                <a:cs typeface="Pretendard"/>
               </a:rPr>
               <a:t>moét × ONVIEW · BEAUTY PLAYGROUND IN SEONGSU</a:t>
             </a:r>
@@ -10185,9 +10185,9 @@
                 <a:solidFill>
                   <a:srgbClr val="CCCCCC"/>
                 </a:solidFill>
-                <a:latin typeface="마루부리"/>
-                <a:ea typeface="마루부리"/>
-                <a:cs typeface="마루부리"/>
+                <a:latin typeface="Pretendard"/>
+                <a:ea typeface="Pretendard"/>
+                <a:cs typeface="Pretendard"/>
               </a:rPr>
               <a:t>09 / 09</a:t>
             </a:r>

</xml_diff>